<commit_message>
docs: lock seisen IF increment estimate and add furigana talk tracks
Refresh the standard/risk packs after the 9/29 master reuse lock, and add bilingual scripts with kana so the 160.5人日 case can be read aloud.

Co-authored-by: Cursor <cursoragent@cursor.com>
</commit_message>
<xml_diff>
--- a/PMI/Sinops/phase2-detail-design/sources/20260921-生鮮IF増分見積/【説明】生鮮IF増分_標準案見積_リスク着眼_20260921.pptx
+++ b/PMI/Sinops/phase2-detail-design/sources/20260921-生鮮IF増分見積/【説明】生鮮IF増分_標準案見積_リスク着眼_20260921.pptx
@@ -3338,7 +3338,7 @@
                 </a:solidFill>
                 <a:latin typeface="Yu Gothic"/>
               </a:rPr>
-              <a:t>資料日 2026-09-21（Rev.e）　出典：標準案 Excel・20260918 生鮮IF会議</a:t>
+              <a:t>資料日 2026-09-30（Rev.i）　出典：マスタデータ判定・標準案 Excel・20260918 生鮮IF会議</a:t>
             </a:r>
           </a:p>
         </p:txBody>
@@ -3532,7 +3532,7 @@
                 </a:solidFill>
                 <a:latin typeface="Yu Gothic"/>
               </a:rPr>
-              <a:t>「生鮮は PMI課題 Sinops非生鮮のPhase2 の外の増分です。本日の提示は221.5人日／7,085,000円です。」</a:t>
+              <a:t>「生鮮は PMI課題 Sinops非生鮮のPhase2 の外の増分です。本日の提示は160.5人日／5,120,000円です。」</a:t>
             </a:r>
           </a:p>
         </p:txBody>
@@ -3621,7 +3621,7 @@
                 </a:solidFill>
                 <a:latin typeface="Yu Gothic"/>
               </a:rPr>
-              <a:t>「ただし生鮮は不確実性が大きい。提示値は前提が成り立つ場合の工数で、確定請負ではありません。」</a:t>
+              <a:t>「提示値は 9/29 マスタデータの判定が成り立つ場合の工数で、確定請負ではありません。」</a:t>
             </a:r>
           </a:p>
         </p:txBody>
@@ -3675,7 +3675,7 @@
                 </a:solidFill>
                 <a:latin typeface="Yu Gothic"/>
               </a:rPr>
-              <a:t>最大変数</a:t>
+              <a:t>判定</a:t>
             </a:r>
           </a:p>
         </p:txBody>
@@ -3710,7 +3710,7 @@
                 </a:solidFill>
                 <a:latin typeface="Yu Gothic"/>
               </a:rPr>
-              <a:t>「最大の変数は専用マスタです。流用可否・本数が未確定で、既存Sinops全体にも効きます。」</a:t>
+              <a:t>「店舗系12本は流用。勧告2ファイルは1.5本換算。発注統合変換は新規。入荷とスケジュールは差分です。」</a:t>
             </a:r>
           </a:p>
         </p:txBody>
@@ -3799,7 +3799,7 @@
                 </a:solidFill>
                 <a:latin typeface="Yu Gothic"/>
               </a:rPr>
-              <a:t>「本案はマスタ流用が概ね成立し、既存波及が限定的な場合の工数です。崩れたら再見積です。」</a:t>
+              <a:t>「判定が覆ったら、本日の数字は無効です。再見積です。」</a:t>
             </a:r>
           </a:p>
         </p:txBody>
@@ -3853,7 +3853,7 @@
                 </a:solidFill>
                 <a:latin typeface="Yu Gothic"/>
               </a:rPr>
-              <a:t>仮置き</a:t>
+              <a:t>B2</a:t>
             </a:r>
           </a:p>
         </p:txBody>
@@ -3888,7 +3888,7 @@
                 </a:solidFill>
                 <a:latin typeface="Yu Gothic"/>
               </a:rPr>
-              <a:t>「B2の51人日は仮置き。B1判定後に確定値へ置換します。」</a:t>
+              <a:t>「マスタ本体IFは0です。水煮相当は午後MTの残件です。」</a:t>
             </a:r>
           </a:p>
         </p:txBody>
@@ -3977,7 +3977,7 @@
                 </a:solidFill>
                 <a:latin typeface="Yu Gothic"/>
               </a:rPr>
-              <a:t>「B1はAのPhase1と並行必須。ゲート後に確定させる進め方でお願いします。」</a:t>
+              <a:t>「12本は突合、6本はマッピングから。B2は0のまま進めます。」</a:t>
             </a:r>
           </a:p>
         </p:txBody>
@@ -4316,7 +4316,7 @@
                 </a:solidFill>
                 <a:latin typeface="Yu Gothic"/>
               </a:rPr>
-              <a:t>221.5人日／¥7,085,000（税抜）
+              <a:t>160.5人日／¥5,120,000（税抜）
 非生鮮Phase2（PMI課題）は据え置き</a:t>
             </a:r>
           </a:p>
@@ -4392,8 +4392,8 @@
                 </a:solidFill>
                 <a:latin typeface="Yu Gothic"/>
               </a:rPr>
-              <a:t>生鮮は不確実性が大
-前提崩壊＝再見積</a:t>
+              <a:t>9/29マスタデータ判定
+覆ったら再見積</a:t>
             </a:r>
           </a:p>
         </p:txBody>
@@ -4468,7 +4468,7 @@
                 </a:solidFill>
                 <a:latin typeface="Yu Gothic"/>
               </a:rPr>
-              <a:t>B1並行 → 判定ゲート → B2置換
+              <a:t>12本突合／6本Mapping／B2＝0
 超過時は再見積</a:t>
             </a:r>
           </a:p>
@@ -4563,7 +4563,7 @@
                 </a:solidFill>
                 <a:latin typeface="Yu Gothic"/>
               </a:rPr>
-              <a:t>・sources/20260918-自動補充PMI-生鮮IF会議/会議記録.md</a:t>
+              <a:t>・20260929_sinops生鮮IF_マスタ部門判定.xlsx</a:t>
             </a:r>
           </a:p>
           <a:p>
@@ -4832,7 +4832,7 @@
                 </a:solidFill>
                 <a:latin typeface="Yu Gothic"/>
               </a:rPr>
-              <a:t>221.5 人日</a:t>
+              <a:t>160.5 人日</a:t>
             </a:r>
           </a:p>
           <a:p>
@@ -4851,7 +4851,7 @@
                 </a:solidFill>
                 <a:latin typeface="Yu Gothic"/>
               </a:rPr>
-              <a:t>直接201.5（P1 59.5＋P2 142）＋PJ20</a:t>
+              <a:t>直接145.5（P1 41.5＋P2 104）＋PJ15</a:t>
             </a:r>
           </a:p>
         </p:txBody>
@@ -4926,7 +4926,7 @@
                 </a:solidFill>
                 <a:latin typeface="Yu Gothic"/>
               </a:rPr>
-              <a:t>¥7,085,000</a:t>
+              <a:t>¥5,120,000</a:t>
             </a:r>
           </a:p>
           <a:p>
@@ -5020,8 +5020,7 @@
                 </a:solidFill>
                 <a:latin typeface="Yu Gothic"/>
               </a:rPr>
-              <a:t>マスタ流用が
-概ね成立</a:t>
+              <a:t>本数は判定済み</a:t>
             </a:r>
           </a:p>
           <a:p>
@@ -5040,8 +5039,8 @@
                 </a:solidFill>
                 <a:latin typeface="Yu Gothic"/>
               </a:rPr>
-              <a:t>既存波及が限定的な場合
-の工数として算定</a:t>
+              <a:t>12本流用・勧告1.5本
+S26新規・入荷は差分</a:t>
             </a:r>
           </a:p>
         </p:txBody>
@@ -5116,7 +5115,7 @@
                 </a:solidFill>
                 <a:latin typeface="Yu Gothic"/>
               </a:rPr>
-              <a:t>・提示値は確定請負ではない。生鮮は不確実性が大きく、前提が崩れたら再見積。</a:t>
+              <a:t>・提示値は確定請負ではない。9/29判定が覆ったら再見積。</a:t>
             </a:r>
           </a:p>
           <a:p>
@@ -5135,7 +5134,7 @@
                 </a:solidFill>
                 <a:latin typeface="Yu Gothic"/>
               </a:rPr>
-              <a:t>・最大の不確実性は生鮮専用マスタの流用可否（B1→B2仮置き）。</a:t>
+              <a:t>・店舗系12本は流用。勧告2ファイルは1.5本換算。発注統合向け変換（S26）は新規。</a:t>
             </a:r>
           </a:p>
           <a:p>
@@ -5154,7 +5153,7 @@
                 </a:solidFill>
                 <a:latin typeface="Yu Gothic"/>
               </a:rPr>
-              <a:t>・B2（マスタIF本体51人日）は仮置き。B1判定後に確定値へ置換する。</a:t>
+              <a:t>・B2（マスタIF本体）は0。倉庫はDC在庫なしで対象外。水煮相当は残件。</a:t>
             </a:r>
           </a:p>
           <a:p>
@@ -5313,7 +5312,7 @@
                 </a:solidFill>
                 <a:latin typeface="Yu Gothic"/>
               </a:rPr>
-              <a:t>2. 見積前提条件（生鮮の不確実性・必読）</a:t>
+              <a:t>2. 見積前提条件（判定済みと残件・必読）</a:t>
             </a:r>
           </a:p>
         </p:txBody>
@@ -5348,7 +5347,7 @@
                 </a:solidFill>
                 <a:latin typeface="Yu Gothic"/>
               </a:rPr>
-              <a:t>提示値は「現時点の前提が成り立つ場合」の工数。確定請負額ではない。</a:t>
+              <a:t>マスタ本数は9/29判定済み。残るのは水煮・GCS・伝票区分・S26項目差・S12/S13のSQLと作成時刻。確定請負ではない。</a:t>
             </a:r>
           </a:p>
         </p:txBody>
@@ -5480,7 +5479,7 @@
                           </a:solidFill>
                           <a:latin typeface="Yu Gothic"/>
                         </a:rPr>
-                        <a:t>専用マスタ多数。非生鮮変換の流用可否・新規本数は未確定</a:t>
+                        <a:t>9/29判定：店舗系12本は非生鮮と同じ（流用）</a:t>
                       </a:r>
                     </a:p>
                   </a:txBody>
@@ -5499,7 +5498,7 @@
                           </a:solidFill>
                           <a:latin typeface="Yu Gothic"/>
                         </a:rPr>
-                        <a:t>B1で1本ずつ三択判定。B2は仮置き</a:t>
+                        <a:t>本体IFは置かない。B1は突合</a:t>
                       </a:r>
                     </a:p>
                   </a:txBody>
@@ -5543,7 +5542,7 @@
                           </a:solidFill>
                           <a:latin typeface="Yu Gothic"/>
                         </a:rPr>
-                        <a:t>マスタ前提変更は PMI課題 Sinops非生鮮のPhase2 にも波及し得る</a:t>
+                        <a:t>判定覆りは PMI課題 Sinops非生鮮のPhase2 にも波及し得る</a:t>
                       </a:r>
                     </a:p>
                   </a:txBody>
@@ -5566,7 +5565,7 @@
                           </a:solidFill>
                           <a:latin typeface="Yu Gothic"/>
                         </a:rPr>
-                        <a:t>B3に波及バッファ。非生鮮Phase2契約額は据え置き</a:t>
+                        <a:t>B3に軽微バッファ。非生鮮Phase2契約額は据え置き</a:t>
                       </a:r>
                     </a:p>
                   </a:txBody>
@@ -5673,7 +5672,7 @@
                           </a:solidFill>
                           <a:latin typeface="Yu Gothic"/>
                         </a:rPr>
-                        <a:t>実績＝2系統ソース、予定＝生鮮基幹新規。非生鮮11/12の単純流用不可</a:t>
+                        <a:t>ベンダー流用。実績＝伝票区分差分＋PC/CK振替。予定・日程＝PC/CKは別SQLでDBGET。作成時刻はやや不安定</a:t>
                       </a:r>
                     </a:p>
                   </a:txBody>
@@ -5696,7 +5695,7 @@
                           </a:solidFill>
                           <a:latin typeface="Yu Gothic"/>
                         </a:rPr>
-                        <a:t>Aで新規IF計上</a:t>
+                        <a:t>Aで差分IF。Layer①にDBGETと待ち合わせ</a:t>
                       </a:r>
                     </a:p>
                   </a:txBody>
@@ -5740,7 +5739,7 @@
                           </a:solidFill>
                           <a:latin typeface="Yu Gothic"/>
                         </a:rPr>
-                        <a:t>生鮮発注統合直／自動発注経由は未確定</a:t>
+                        <a:t>現行生鮮→統合IFは流用不可。非生鮮24/25発注IFを参照して変換IFを新規</a:t>
                       </a:r>
                     </a:p>
                   </a:txBody>
@@ -5759,7 +5758,7 @@
                           </a:solidFill>
                           <a:latin typeface="Yu Gothic"/>
                         </a:rPr>
-                        <a:t>連携先変更時は再見積</a:t>
+                        <a:t>AでS26を計上</a:t>
                       </a:r>
                     </a:p>
                   </a:txBody>
@@ -5780,7 +5779,7 @@
                           </a:solidFill>
                           <a:latin typeface="Yu Gothic"/>
                         </a:rPr>
-                        <a:t>棚割・在庫</a:t>
+                        <a:t>倉庫</a:t>
                       </a:r>
                     </a:p>
                   </a:txBody>
@@ -5803,7 +5802,7 @@
                           </a:solidFill>
                           <a:latin typeface="Yu Gothic"/>
                         </a:rPr>
-                        <a:t>SM vs 新棚割未確定。営業在庫の生鮮適用は未検証</a:t>
+                        <a:t>DC在庫なし。倉庫商品マスタ（水煮相当）は残件</a:t>
                       </a:r>
                     </a:p>
                   </a:txBody>
@@ -5826,7 +5825,7 @@
                           </a:solidFill>
                           <a:latin typeface="Yu Gothic"/>
                         </a:rPr>
-                        <a:t>方針確定・検証結果で再見積</a:t>
+                        <a:t>倉庫系は対象外。要IFなら再見積</a:t>
                       </a:r>
                     </a:p>
                   </a:txBody>
@@ -5870,7 +5869,7 @@
                           </a:solidFill>
                           <a:latin typeface="Yu Gothic"/>
                         </a:rPr>
-                        <a:t>マスタ流用が概ね成立し、既存波及が限定的</a:t>
+                        <a:t>9/29判定が成り立つ</a:t>
                       </a:r>
                     </a:p>
                   </a:txBody>
@@ -6105,7 +6104,7 @@
                 </a:solidFill>
                 <a:latin typeface="Yu Gothic"/>
               </a:rPr>
-              <a:t>A（先行トラン）は比較的確定。B（マスタ横断）が不確実性の本体。</a:t>
+              <a:t>A（確定IF）が本体。B2は0。S12/S13にDBGETを加算。</a:t>
             </a:r>
           </a:p>
         </p:txBody>
@@ -6285,7 +6284,7 @@
                           </a:solidFill>
                           <a:latin typeface="Yu Gothic"/>
                         </a:rPr>
-                        <a:t>先行トラン（新規IF 4本）</a:t>
+                        <a:t>確定IF（勧告1.5＋変換1＋入荷2＋日程1）</a:t>
                       </a:r>
                     </a:p>
                   </a:txBody>
@@ -6304,7 +6303,7 @@
                           </a:solidFill>
                           <a:latin typeface="Yu Gothic"/>
                         </a:rPr>
-                        <a:t>100.5</a:t>
+                        <a:t>125.5</a:t>
                       </a:r>
                     </a:p>
                   </a:txBody>
@@ -6323,7 +6322,7 @@
                           </a:solidFill>
                           <a:latin typeface="Yu Gothic"/>
                         </a:rPr>
-                        <a:t>3,070,000</a:t>
+                        <a:t>3,782,500</a:t>
                       </a:r>
                     </a:p>
                   </a:txBody>
@@ -6342,7 +6341,7 @@
                           </a:solidFill>
                           <a:latin typeface="Yu Gothic"/>
                         </a:rPr>
-                        <a:t>中（P1+P2単価混在）</a:t>
+                        <a:t>中（S12/S13にDBGET）</a:t>
                       </a:r>
                     </a:p>
                   </a:txBody>
@@ -6386,7 +6385,7 @@
                           </a:solidFill>
                           <a:latin typeface="Yu Gothic"/>
                         </a:rPr>
-                        <a:t>マスタ棚卸・判定（必須）</a:t>
+                        <a:t>流用突合・倉庫対象外・GCS・残件</a:t>
                       </a:r>
                     </a:p>
                   </a:txBody>
@@ -6409,7 +6408,7 @@
                           </a:solidFill>
                           <a:latin typeface="Yu Gothic"/>
                         </a:rPr>
-                        <a:t>35</a:t>
+                        <a:t>15</a:t>
                       </a:r>
                     </a:p>
                   </a:txBody>
@@ -6432,7 +6431,7 @@
                           </a:solidFill>
                           <a:latin typeface="Yu Gothic"/>
                         </a:rPr>
-                        <a:t>1,400,000</a:t>
+                        <a:t>600,000</a:t>
                       </a:r>
                     </a:p>
                   </a:txBody>
@@ -6455,7 +6454,7 @@
                           </a:solidFill>
                           <a:latin typeface="Yu Gothic"/>
                         </a:rPr>
-                        <a:t>高（Phase1単価40,000）</a:t>
+                        <a:t>中（Phase1単価40,000）</a:t>
                       </a:r>
                     </a:p>
                   </a:txBody>
@@ -6499,7 +6498,7 @@
                           </a:solidFill>
                           <a:latin typeface="Yu Gothic"/>
                         </a:rPr>
-                        <a:t>マスタIF本体（仮置き）</a:t>
+                        <a:t>マスタIF本体</a:t>
                       </a:r>
                     </a:p>
                   </a:txBody>
@@ -6518,7 +6517,7 @@
                           </a:solidFill>
                           <a:latin typeface="Yu Gothic"/>
                         </a:rPr>
-                        <a:t>51</a:t>
+                        <a:t>0</a:t>
                       </a:r>
                     </a:p>
                   </a:txBody>
@@ -6537,7 +6536,7 @@
                           </a:solidFill>
                           <a:latin typeface="Yu Gothic"/>
                         </a:rPr>
-                        <a:t>1,402,500</a:t>
+                        <a:t>0</a:t>
                       </a:r>
                     </a:p>
                   </a:txBody>
@@ -6556,7 +6555,7 @@
                           </a:solidFill>
                           <a:latin typeface="Yu Gothic"/>
                         </a:rPr>
-                        <a:t>最高（Phase2直接27,500）</a:t>
+                        <a:t>流用確定のため0</a:t>
                       </a:r>
                     </a:p>
                   </a:txBody>
@@ -6623,7 +6622,7 @@
                           </a:solidFill>
                           <a:latin typeface="Yu Gothic"/>
                         </a:rPr>
-                        <a:t>15</a:t>
+                        <a:t>5</a:t>
                       </a:r>
                     </a:p>
                   </a:txBody>
@@ -6646,7 +6645,7 @@
                           </a:solidFill>
                           <a:latin typeface="Yu Gothic"/>
                         </a:rPr>
-                        <a:t>412,500</a:t>
+                        <a:t>137,500</a:t>
                       </a:r>
                     </a:p>
                   </a:txBody>
@@ -6669,7 +6668,7 @@
                           </a:solidFill>
                           <a:latin typeface="Yu Gothic"/>
                         </a:rPr>
-                        <a:t>高（Phase2直接27,500）</a:t>
+                        <a:t>低（Phase2直接27,500）</a:t>
                       </a:r>
                     </a:p>
                   </a:txBody>
@@ -6732,7 +6731,7 @@
                           </a:solidFill>
                           <a:latin typeface="Yu Gothic"/>
                         </a:rPr>
-                        <a:t>201.5</a:t>
+                        <a:t>145.5</a:t>
                       </a:r>
                     </a:p>
                   </a:txBody>
@@ -6751,7 +6750,7 @@
                           </a:solidFill>
                           <a:latin typeface="Yu Gothic"/>
                         </a:rPr>
-                        <a:t>6,285,000</a:t>
+                        <a:t>4,520,000</a:t>
                       </a:r>
                     </a:p>
                   </a:txBody>
@@ -6828,7 +6827,7 @@
                           </a:solidFill>
                           <a:latin typeface="Yu Gothic"/>
                         </a:rPr>
-                        <a:t>20</a:t>
+                        <a:t>15</a:t>
                       </a:r>
                     </a:p>
                   </a:txBody>
@@ -6851,7 +6850,7 @@
                           </a:solidFill>
                           <a:latin typeface="Yu Gothic"/>
                         </a:rPr>
-                        <a:t>800,000</a:t>
+                        <a:t>600,000</a:t>
                       </a:r>
                     </a:p>
                   </a:txBody>
@@ -6945,7 +6944,7 @@
                           </a:solidFill>
                           <a:latin typeface="Yu Gothic"/>
                         </a:rPr>
-                        <a:t>221.5</a:t>
+                        <a:t>160.5</a:t>
                       </a:r>
                     </a:p>
                   </a:txBody>
@@ -6968,7 +6967,7 @@
                           </a:solidFill>
                           <a:latin typeface="Yu Gothic"/>
                         </a:rPr>
-                        <a:t>7,085,000</a:t>
+                        <a:t>5,120,000</a:t>
                       </a:r>
                     </a:p>
                   </a:txBody>
@@ -7167,7 +7166,7 @@
                 </a:solidFill>
                 <a:latin typeface="Yu Gothic"/>
               </a:rPr>
-              <a:t>4. A｜先行トラン4本（比較的見えている範囲）</a:t>
+              <a:t>4. A｜確定IF（勧告は1.5本換算）</a:t>
             </a:r>
           </a:p>
         </p:txBody>
@@ -7202,7 +7201,7 @@
                 </a:solidFill>
                 <a:latin typeface="Yu Gothic"/>
               </a:rPr>
-              <a:t>会議結論：非生鮮24/25・11/12の流用不可 → 新規IF必須</a:t>
+              <a:t>当日1本＋翌日0.5本。発注統合変換は別1本。入荷・スケジュールは差分</a:t>
             </a:r>
           </a:p>
         </p:txBody>
@@ -7217,7 +7216,7 @@
         </p:nvGraphicFramePr>
         <p:xfrm>
           <a:off x="274320" y="1234440"/>
-          <a:ext cx="11521440" cy="1755648"/>
+          <a:ext cx="11521440" cy="2340864"/>
         </p:xfrm>
         <a:graphic>
           <a:graphicData uri="http://schemas.openxmlformats.org/drawingml/2006/table">
@@ -7386,7 +7385,7 @@
                           </a:solidFill>
                           <a:latin typeface="Yu Gothic"/>
                         </a:rPr>
-                        <a:t>なぜ新規か</a:t>
+                        <a:t>なぜ置くか</a:t>
                       </a:r>
                     </a:p>
                   </a:txBody>
@@ -7449,7 +7448,7 @@
                           </a:solidFill>
                           <a:latin typeface="Yu Gothic"/>
                         </a:rPr>
-                        <a:t>6.0</a:t>
+                        <a:t>5.0</a:t>
                       </a:r>
                     </a:p>
                   </a:txBody>
@@ -7506,7 +7505,7 @@
                           </a:solidFill>
                           <a:latin typeface="Yu Gothic"/>
                         </a:rPr>
-                        <a:t>27.5</a:t>
+                        <a:t>26.5</a:t>
                       </a:r>
                     </a:p>
                   </a:txBody>
@@ -7525,7 +7524,7 @@
                           </a:solidFill>
                           <a:latin typeface="Yu Gothic"/>
                         </a:rPr>
-                        <a:t>項目・ファイルが非生鮮と違う／連携先＝生鮮発注統合</a:t>
+                        <a:t>Sinops勧告。1.0本</a:t>
                       </a:r>
                     </a:p>
                   </a:txBody>
@@ -7592,7 +7591,7 @@
                           </a:solidFill>
                           <a:latin typeface="Yu Gothic"/>
                         </a:rPr>
-                        <a:t>4.5</a:t>
+                        <a:t>2.5</a:t>
                       </a:r>
                     </a:p>
                   </a:txBody>
@@ -7615,7 +7614,7 @@
                           </a:solidFill>
                           <a:latin typeface="Yu Gothic"/>
                         </a:rPr>
-                        <a:t>14.0</a:t>
+                        <a:t>8.5</a:t>
                       </a:r>
                     </a:p>
                   </a:txBody>
@@ -7638,7 +7637,7 @@
                           </a:solidFill>
                           <a:latin typeface="Yu Gothic"/>
                         </a:rPr>
-                        <a:t>3.0</a:t>
+                        <a:t>2.5</a:t>
                       </a:r>
                     </a:p>
                   </a:txBody>
@@ -7661,7 +7660,7 @@
                           </a:solidFill>
                           <a:latin typeface="Yu Gothic"/>
                         </a:rPr>
-                        <a:t>21.5</a:t>
+                        <a:t>13.5</a:t>
                       </a:r>
                     </a:p>
                   </a:txBody>
@@ -7684,7 +7683,7 @@
                           </a:solidFill>
                           <a:latin typeface="Yu Gothic"/>
                         </a:rPr>
-                        <a:t>未来スロット差分。当日と類似だが別行</a:t>
+                        <a:t>当日類似。0.5本換算</a:t>
                       </a:r>
                     </a:p>
                   </a:txBody>
@@ -7709,7 +7708,7 @@
                           </a:solidFill>
                           <a:latin typeface="Yu Gothic"/>
                         </a:rPr>
-                        <a:t>入荷実績</a:t>
+                        <a:t>勧告→発注統合変換</a:t>
                       </a:r>
                     </a:p>
                   </a:txBody>
@@ -7728,7 +7727,7 @@
                           </a:solidFill>
                           <a:latin typeface="Yu Gothic"/>
                         </a:rPr>
-                        <a:t>S11</a:t>
+                        <a:t>S26</a:t>
                       </a:r>
                     </a:p>
                   </a:txBody>
@@ -7747,7 +7746,7 @@
                           </a:solidFill>
                           <a:latin typeface="Yu Gothic"/>
                         </a:rPr>
-                        <a:t>8.0</a:t>
+                        <a:t>5.0</a:t>
                       </a:r>
                     </a:p>
                   </a:txBody>
@@ -7766,7 +7765,7 @@
                           </a:solidFill>
                           <a:latin typeface="Yu Gothic"/>
                         </a:rPr>
-                        <a:t>17.0</a:t>
+                        <a:t>14.0</a:t>
                       </a:r>
                     </a:p>
                   </a:txBody>
@@ -7785,7 +7784,7 @@
                           </a:solidFill>
                           <a:latin typeface="Yu Gothic"/>
                         </a:rPr>
-                        <a:t>4.0</a:t>
+                        <a:t>3.0</a:t>
                       </a:r>
                     </a:p>
                   </a:txBody>
@@ -7804,7 +7803,7 @@
                           </a:solidFill>
                           <a:latin typeface="Yu Gothic"/>
                         </a:rPr>
-                        <a:t>29.0</a:t>
+                        <a:t>22.0</a:t>
                       </a:r>
                     </a:p>
                   </a:txBody>
@@ -7823,7 +7822,7 @@
                           </a:solidFill>
                           <a:latin typeface="Yu Gothic"/>
                         </a:rPr>
-                        <a:t>2系統（PC/CK＝生鮮基幹、取引先＝MD基幹）</a:t>
+                        <a:t>現行生鮮→統合IFは使わない。非生鮮24/25参照</a:t>
                       </a:r>
                     </a:p>
                   </a:txBody>
@@ -7844,7 +7843,7 @@
                           </a:solidFill>
                           <a:latin typeface="Yu Gothic"/>
                         </a:rPr>
-                        <a:t>入荷予定</a:t>
+                        <a:t>入荷実績</a:t>
                       </a:r>
                     </a:p>
                   </a:txBody>
@@ -7867,7 +7866,7 @@
                           </a:solidFill>
                           <a:latin typeface="Yu Gothic"/>
                         </a:rPr>
-                        <a:t>S12</a:t>
+                        <a:t>S11</a:t>
                       </a:r>
                     </a:p>
                   </a:txBody>
@@ -7890,7 +7889,7 @@
                           </a:solidFill>
                           <a:latin typeface="Yu Gothic"/>
                         </a:rPr>
-                        <a:t>6.0</a:t>
+                        <a:t>4.0</a:t>
                       </a:r>
                     </a:p>
                   </a:txBody>
@@ -7913,7 +7912,7 @@
                           </a:solidFill>
                           <a:latin typeface="Yu Gothic"/>
                         </a:rPr>
-                        <a:t>14.0</a:t>
+                        <a:t>12.0</a:t>
                       </a:r>
                     </a:p>
                   </a:txBody>
@@ -7959,7 +7958,7 @@
                           </a:solidFill>
                           <a:latin typeface="Yu Gothic"/>
                         </a:rPr>
-                        <a:t>22.5</a:t>
+                        <a:t>18.5</a:t>
                       </a:r>
                     </a:p>
                   </a:txBody>
@@ -7982,7 +7981,7 @@
                           </a:solidFill>
                           <a:latin typeface="Yu Gothic"/>
                         </a:rPr>
-                        <a:t>生鮮基幹が新ソース。Layer①別作</a:t>
+                        <a:t>ベンダー流用。伝票区分差分＋PC/CK振替</a:t>
                       </a:r>
                     </a:p>
                   </a:txBody>
@@ -8007,6 +8006,304 @@
                           </a:solidFill>
                           <a:latin typeface="Yu Gothic"/>
                         </a:rPr>
+                        <a:t>入荷予定</a:t>
+                      </a:r>
+                    </a:p>
+                  </a:txBody>
+                  <a:tcPr anchor="ctr"/>
+                </a:tc>
+                <a:tc>
+                  <a:txBody>
+                    <a:bodyPr/>
+                    <a:lstStyle/>
+                    <a:p>
+                      <a:pPr algn="l"/>
+                      <a:r>
+                        <a:rPr sz="1100" b="0">
+                          <a:solidFill>
+                            <a:srgbClr val="2F2F2F"/>
+                          </a:solidFill>
+                          <a:latin typeface="Yu Gothic"/>
+                        </a:rPr>
+                        <a:t>S12</a:t>
+                      </a:r>
+                    </a:p>
+                  </a:txBody>
+                  <a:tcPr anchor="ctr"/>
+                </a:tc>
+                <a:tc>
+                  <a:txBody>
+                    <a:bodyPr/>
+                    <a:lstStyle/>
+                    <a:p>
+                      <a:pPr algn="l"/>
+                      <a:r>
+                        <a:rPr sz="1100" b="0">
+                          <a:solidFill>
+                            <a:srgbClr val="2F2F2F"/>
+                          </a:solidFill>
+                          <a:latin typeface="Yu Gothic"/>
+                        </a:rPr>
+                        <a:t>5.0</a:t>
+                      </a:r>
+                    </a:p>
+                  </a:txBody>
+                  <a:tcPr anchor="ctr"/>
+                </a:tc>
+                <a:tc>
+                  <a:txBody>
+                    <a:bodyPr/>
+                    <a:lstStyle/>
+                    <a:p>
+                      <a:pPr algn="l"/>
+                      <a:r>
+                        <a:rPr sz="1100" b="0">
+                          <a:solidFill>
+                            <a:srgbClr val="2F2F2F"/>
+                          </a:solidFill>
+                          <a:latin typeface="Yu Gothic"/>
+                        </a:rPr>
+                        <a:t>15.0</a:t>
+                      </a:r>
+                    </a:p>
+                  </a:txBody>
+                  <a:tcPr anchor="ctr"/>
+                </a:tc>
+                <a:tc>
+                  <a:txBody>
+                    <a:bodyPr/>
+                    <a:lstStyle/>
+                    <a:p>
+                      <a:pPr algn="l"/>
+                      <a:r>
+                        <a:rPr sz="1100" b="0">
+                          <a:solidFill>
+                            <a:srgbClr val="2F2F2F"/>
+                          </a:solidFill>
+                          <a:latin typeface="Yu Gothic"/>
+                        </a:rPr>
+                        <a:t>2.5</a:t>
+                      </a:r>
+                    </a:p>
+                  </a:txBody>
+                  <a:tcPr anchor="ctr"/>
+                </a:tc>
+                <a:tc>
+                  <a:txBody>
+                    <a:bodyPr/>
+                    <a:lstStyle/>
+                    <a:p>
+                      <a:pPr algn="l"/>
+                      <a:r>
+                        <a:rPr sz="1100" b="0">
+                          <a:solidFill>
+                            <a:srgbClr val="2F2F2F"/>
+                          </a:solidFill>
+                          <a:latin typeface="Yu Gothic"/>
+                        </a:rPr>
+                        <a:t>22.5</a:t>
+                      </a:r>
+                    </a:p>
+                  </a:txBody>
+                  <a:tcPr anchor="ctr"/>
+                </a:tc>
+                <a:tc>
+                  <a:txBody>
+                    <a:bodyPr/>
+                    <a:lstStyle/>
+                    <a:p>
+                      <a:pPr algn="l"/>
+                      <a:r>
+                        <a:rPr sz="1100" b="0">
+                          <a:solidFill>
+                            <a:srgbClr val="2F2F2F"/>
+                          </a:solidFill>
+                          <a:latin typeface="Yu Gothic"/>
+                        </a:rPr>
+                        <a:t>ベンダー流用。PC/CKは別SQL。DBGET2系統＋待ち合わせ</a:t>
+                      </a:r>
+                    </a:p>
+                  </a:txBody>
+                  <a:tcPr anchor="ctr"/>
+                </a:tc>
+              </a:tr>
+              <a:tr h="292608">
+                <a:tc>
+                  <a:txBody>
+                    <a:bodyPr/>
+                    <a:lstStyle/>
+                    <a:p>
+                      <a:pPr algn="ctr"/>
+                      <a:r>
+                        <a:rPr sz="1100" b="0">
+                          <a:solidFill>
+                            <a:srgbClr val="2F2F2F"/>
+                          </a:solidFill>
+                          <a:latin typeface="Yu Gothic"/>
+                        </a:rPr>
+                        <a:t>発注スケジュール</a:t>
+                      </a:r>
+                    </a:p>
+                  </a:txBody>
+                  <a:tcPr anchor="ctr">
+                    <a:solidFill>
+                      <a:srgbClr val="F5F8FB"/>
+                    </a:solidFill>
+                  </a:tcPr>
+                </a:tc>
+                <a:tc>
+                  <a:txBody>
+                    <a:bodyPr/>
+                    <a:lstStyle/>
+                    <a:p>
+                      <a:pPr algn="l"/>
+                      <a:r>
+                        <a:rPr sz="1100" b="0">
+                          <a:solidFill>
+                            <a:srgbClr val="2F2F2F"/>
+                          </a:solidFill>
+                          <a:latin typeface="Yu Gothic"/>
+                        </a:rPr>
+                        <a:t>S13</a:t>
+                      </a:r>
+                    </a:p>
+                  </a:txBody>
+                  <a:tcPr anchor="ctr">
+                    <a:solidFill>
+                      <a:srgbClr val="F5F8FB"/>
+                    </a:solidFill>
+                  </a:tcPr>
+                </a:tc>
+                <a:tc>
+                  <a:txBody>
+                    <a:bodyPr/>
+                    <a:lstStyle/>
+                    <a:p>
+                      <a:pPr algn="l"/>
+                      <a:r>
+                        <a:rPr sz="1100" b="0">
+                          <a:solidFill>
+                            <a:srgbClr val="2F2F2F"/>
+                          </a:solidFill>
+                          <a:latin typeface="Yu Gothic"/>
+                        </a:rPr>
+                        <a:t>5.0</a:t>
+                      </a:r>
+                    </a:p>
+                  </a:txBody>
+                  <a:tcPr anchor="ctr">
+                    <a:solidFill>
+                      <a:srgbClr val="F5F8FB"/>
+                    </a:solidFill>
+                  </a:tcPr>
+                </a:tc>
+                <a:tc>
+                  <a:txBody>
+                    <a:bodyPr/>
+                    <a:lstStyle/>
+                    <a:p>
+                      <a:pPr algn="l"/>
+                      <a:r>
+                        <a:rPr sz="1100" b="0">
+                          <a:solidFill>
+                            <a:srgbClr val="2F2F2F"/>
+                          </a:solidFill>
+                          <a:latin typeface="Yu Gothic"/>
+                        </a:rPr>
+                        <a:t>15.0</a:t>
+                      </a:r>
+                    </a:p>
+                  </a:txBody>
+                  <a:tcPr anchor="ctr">
+                    <a:solidFill>
+                      <a:srgbClr val="F5F8FB"/>
+                    </a:solidFill>
+                  </a:tcPr>
+                </a:tc>
+                <a:tc>
+                  <a:txBody>
+                    <a:bodyPr/>
+                    <a:lstStyle/>
+                    <a:p>
+                      <a:pPr algn="l"/>
+                      <a:r>
+                        <a:rPr sz="1100" b="0">
+                          <a:solidFill>
+                            <a:srgbClr val="2F2F2F"/>
+                          </a:solidFill>
+                          <a:latin typeface="Yu Gothic"/>
+                        </a:rPr>
+                        <a:t>2.5</a:t>
+                      </a:r>
+                    </a:p>
+                  </a:txBody>
+                  <a:tcPr anchor="ctr">
+                    <a:solidFill>
+                      <a:srgbClr val="F5F8FB"/>
+                    </a:solidFill>
+                  </a:tcPr>
+                </a:tc>
+                <a:tc>
+                  <a:txBody>
+                    <a:bodyPr/>
+                    <a:lstStyle/>
+                    <a:p>
+                      <a:pPr algn="l"/>
+                      <a:r>
+                        <a:rPr sz="1100" b="0">
+                          <a:solidFill>
+                            <a:srgbClr val="2F2F2F"/>
+                          </a:solidFill>
+                          <a:latin typeface="Yu Gothic"/>
+                        </a:rPr>
+                        <a:t>22.5</a:t>
+                      </a:r>
+                    </a:p>
+                  </a:txBody>
+                  <a:tcPr anchor="ctr">
+                    <a:solidFill>
+                      <a:srgbClr val="F5F8FB"/>
+                    </a:solidFill>
+                  </a:tcPr>
+                </a:tc>
+                <a:tc>
+                  <a:txBody>
+                    <a:bodyPr/>
+                    <a:lstStyle/>
+                    <a:p>
+                      <a:pPr algn="l"/>
+                      <a:r>
+                        <a:rPr sz="1100" b="0">
+                          <a:solidFill>
+                            <a:srgbClr val="2F2F2F"/>
+                          </a:solidFill>
+                          <a:latin typeface="Yu Gothic"/>
+                        </a:rPr>
+                        <a:t>ベンダー流用。PC/CKは別SQL。DBGET2系統＋待ち合わせ</a:t>
+                      </a:r>
+                    </a:p>
+                  </a:txBody>
+                  <a:tcPr anchor="ctr">
+                    <a:solidFill>
+                      <a:srgbClr val="F5F8FB"/>
+                    </a:solidFill>
+                  </a:tcPr>
+                </a:tc>
+              </a:tr>
+              <a:tr h="292608">
+                <a:tc>
+                  <a:txBody>
+                    <a:bodyPr/>
+                    <a:lstStyle/>
+                    <a:p>
+                      <a:pPr algn="ctr"/>
+                      <a:r>
+                        <a:rPr sz="1100" b="0">
+                          <a:solidFill>
+                            <a:srgbClr val="2F2F2F"/>
+                          </a:solidFill>
+                          <a:latin typeface="Yu Gothic"/>
+                        </a:rPr>
                         <a:t>A小計</a:t>
                       </a:r>
                     </a:p>
@@ -8044,7 +8341,7 @@
                           </a:solidFill>
                           <a:latin typeface="Yu Gothic"/>
                         </a:rPr>
-                        <a:t>24.5</a:t>
+                        <a:t>26.5</a:t>
                       </a:r>
                     </a:p>
                   </a:txBody>
@@ -8067,7 +8364,7 @@
                           </a:solidFill>
                           <a:latin typeface="Yu Gothic"/>
                         </a:rPr>
-                        <a:t>62.0</a:t>
+                        <a:t>81.5</a:t>
                       </a:r>
                     </a:p>
                   </a:txBody>
@@ -8090,7 +8387,7 @@
                           </a:solidFill>
                           <a:latin typeface="Yu Gothic"/>
                         </a:rPr>
-                        <a:t>14.0</a:t>
+                        <a:t>17.5</a:t>
                       </a:r>
                     </a:p>
                   </a:txBody>
@@ -8113,7 +8410,7 @@
                           </a:solidFill>
                           <a:latin typeface="Yu Gothic"/>
                         </a:rPr>
-                        <a:t>100.5</a:t>
+                        <a:t>125.5</a:t>
                       </a:r>
                     </a:p>
                   </a:txBody>
@@ -8136,7 +8433,7 @@
                           </a:solidFill>
                           <a:latin typeface="Yu Gothic"/>
                         </a:rPr>
-                        <a:t>Layer②＝0（全件）</a:t>
+                        <a:t>勧告2ファイル＝1.5本。Layer②＝0</a:t>
                       </a:r>
                     </a:p>
                   </a:txBody>
@@ -8221,7 +8518,7 @@
                 </a:solidFill>
                 <a:latin typeface="Yu Gothic"/>
               </a:rPr>
-              <a:t>要件の骨格は 9/18 会議で先行確定。残リスクは項目精査・2系統合流設計・連携先経路の細部。本数確定前の大幅上振れは、B1判定後の再見積で扱う。</a:t>
+              <a:t>要件の骨格は 9/18 会議。本数判定は 9/29。残リスクは項目精査・伝票区分・GCS、発注統合レイアウト差、S12/S13のSQLと作成時刻。覆りは再見積。</a:t>
             </a:r>
           </a:p>
         </p:txBody>
@@ -8361,7 +8658,7 @@
                 </a:solidFill>
                 <a:latin typeface="Yu Gothic"/>
               </a:rPr>
-              <a:t>5. 最重要リスク｜生鮮専用マスタ（見積の心臓部）</a:t>
+              <a:t>5. 最重要リスク｜判定後に残るもの</a:t>
             </a:r>
           </a:p>
         </p:txBody>
@@ -8396,7 +8693,7 @@
                 </a:solidFill>
                 <a:latin typeface="Yu Gothic"/>
               </a:rPr>
-              <a:t>ここを説明しないと、提示値は「根拠のない楽観」に見える</a:t>
+              <a:t>12本流用は確定。残件はGCS・伝票区分・水煮・SQL作成時刻</a:t>
             </a:r>
           </a:p>
         </p:txBody>
@@ -8452,7 +8749,7 @@
                 </a:solidFill>
                 <a:latin typeface="Yu Gothic"/>
               </a:rPr>
-              <a:t>何が未確定か</a:t>
+              <a:t>判定で決まったこと</a:t>
             </a:r>
           </a:p>
           <a:p>
@@ -8471,7 +8768,7 @@
                 </a:solidFill>
                 <a:latin typeface="Yu Gothic"/>
               </a:rPr>
-              <a:t>・生鮮は専用マスタを大量に持つ</a:t>
+              <a:t>・店舗系12本は非生鮮と同じ（流用）</a:t>
             </a:r>
           </a:p>
           <a:p>
@@ -8490,7 +8787,7 @@
                 </a:solidFill>
                 <a:latin typeface="Yu Gothic"/>
               </a:rPr>
-              <a:t>・非生鮮の③変換ルールで足りるか未確認</a:t>
+              <a:t>・本体IFは置かない（B2＝0）</a:t>
             </a:r>
           </a:p>
           <a:p>
@@ -8509,7 +8806,7 @@
                 </a:solidFill>
                 <a:latin typeface="Yu Gothic"/>
               </a:rPr>
-              <a:t>・流用／差分／新規の本数が未確定</a:t>
+              <a:t>・勧告ファイル2本は新規。発注統合変換も新規</a:t>
             </a:r>
           </a:p>
           <a:p>
@@ -8528,7 +8825,7 @@
                 </a:solidFill>
                 <a:latin typeface="Yu Gothic"/>
               </a:rPr>
-              <a:t>・影響は先行4本に閉じず Sinops 全体</a:t>
+              <a:t>・入荷・スケジュールはベンダー流用＋差分</a:t>
             </a:r>
           </a:p>
           <a:p>
@@ -8547,7 +8844,7 @@
                 </a:solidFill>
                 <a:latin typeface="Yu Gothic"/>
               </a:rPr>
-              <a:t>・源：生鮮側サーバー→GCS（無い見込み）</a:t>
+              <a:t>・倉庫系はDC在庫なしで対象外</a:t>
             </a:r>
           </a:p>
           <a:p>
@@ -8566,7 +8863,7 @@
                 </a:solidFill>
                 <a:latin typeface="Yu Gothic"/>
               </a:rPr>
-              <a:t>・候補例：TM商品、店別差分、カテゴリ、</a:t>
+              <a:t>・影響は先行IFに閉じないが、</a:t>
             </a:r>
           </a:p>
           <a:p>
@@ -8585,26 +8882,7 @@
                 </a:solidFill>
                 <a:latin typeface="Yu Gothic"/>
               </a:rPr>
-              <a:t>　仕入先、停止フラグ、発注スケジュール、</a:t>
-            </a:r>
-          </a:p>
-          <a:p>
-            <a:pPr algn="l">
-              <a:spcBef>
-                <a:spcPts val="800"/>
-              </a:spcBef>
-              <a:spcAft>
-                <a:spcPts val="200"/>
-              </a:spcAft>
-            </a:pPr>
-            <a:r>
-              <a:rPr sz="1400" b="0">
-                <a:solidFill>
-                  <a:srgbClr val="2F2F2F"/>
-                </a:solidFill>
-                <a:latin typeface="Yu Gothic"/>
-              </a:rPr>
-              <a:t>　棚割14／新商品在庫15 など</a:t>
+              <a:t>　流用前提が覆ったときだけ横断が増える</a:t>
             </a:r>
           </a:p>
         </p:txBody>
@@ -8679,7 +8957,7 @@
                 </a:solidFill>
                 <a:latin typeface="Yu Gothic"/>
               </a:rPr>
-              <a:t>B1 35人日＝判定そのもの（必須・並行着手）</a:t>
+              <a:t>B1 15人日＝突合と残件</a:t>
             </a:r>
           </a:p>
           <a:p>
@@ -8698,7 +8976,7 @@
                 </a:solidFill>
                 <a:latin typeface="Yu Gothic"/>
               </a:rPr>
-              <a:t>　一覧化／1本ずつ三択判定／既存影響／</a:t>
+              <a:t>　流用12本突合8／倉庫対象外2／</a:t>
             </a:r>
           </a:p>
           <a:p>
@@ -8717,7 +8995,7 @@
                 </a:solidFill>
                 <a:latin typeface="Yu Gothic"/>
               </a:rPr>
-              <a:t>　GCSアップロード確認／ゲート資料・再見積更新</a:t>
+              <a:t>　GCS確認3／水煮残件2</a:t>
             </a:r>
           </a:p>
           <a:p>
@@ -8755,7 +9033,7 @@
                 </a:solidFill>
                 <a:latin typeface="Yu Gothic"/>
               </a:rPr>
-              <a:t>B2 51人日＝仮置き（3本×17人日想定）</a:t>
+              <a:t>B2 0人日＝マスタ本体IFなし</a:t>
             </a:r>
           </a:p>
           <a:p>
@@ -8774,7 +9052,7 @@
                 </a:solidFill>
                 <a:latin typeface="Yu Gothic"/>
               </a:rPr>
-              <a:t>　→ B1後に確定値へ置換</a:t>
+              <a:t> </a:t>
             </a:r>
           </a:p>
           <a:p>
@@ -8793,7 +9071,7 @@
                 </a:solidFill>
                 <a:latin typeface="Yu Gothic"/>
               </a:rPr>
-              <a:t> </a:t>
+              <a:t>B3 5人日＝伝票区分・振替の軽微注記</a:t>
             </a:r>
           </a:p>
           <a:p>
@@ -8812,7 +9090,7 @@
                 </a:solidFill>
                 <a:latin typeface="Yu Gothic"/>
               </a:rPr>
-              <a:t>B3 15人日＝非生鮮Phase2（PMI課題）への軽微波及バッファ</a:t>
+              <a:t> </a:t>
             </a:r>
           </a:p>
           <a:p>
@@ -8831,26 +9109,7 @@
                 </a:solidFill>
                 <a:latin typeface="Yu Gothic"/>
               </a:rPr>
-              <a:t> </a:t>
-            </a:r>
-          </a:p>
-          <a:p>
-            <a:pPr algn="l">
-              <a:spcBef>
-                <a:spcPts val="500"/>
-              </a:spcBef>
-              <a:spcAft>
-                <a:spcPts val="200"/>
-              </a:spcAft>
-            </a:pPr>
-            <a:r>
-              <a:rPr sz="1400" b="0">
-                <a:solidFill>
-                  <a:srgbClr val="2F2F2F"/>
-                </a:solidFill>
-                <a:latin typeface="Yu Gothic"/>
-              </a:rPr>
-              <a:t>※ B を A と並行必須（後追いすると手戻り）</a:t>
+              <a:t>※ 覆ったらリスク込み案で再見積</a:t>
             </a:r>
           </a:p>
         </p:txBody>
@@ -9040,7 +9299,7 @@
         </p:nvGraphicFramePr>
         <p:xfrm>
           <a:off x="274320" y="1234440"/>
-          <a:ext cx="11704320" cy="2048256"/>
+          <a:ext cx="11704320" cy="2340864"/>
         </p:xfrm>
         <a:graphic>
           <a:graphicData uri="http://schemas.openxmlformats.org/drawingml/2006/table">
@@ -9138,7 +9397,7 @@
                           </a:solidFill>
                           <a:latin typeface="Yu Gothic"/>
                         </a:rPr>
-                        <a:t>01/02 商品・店別</a:t>
+                        <a:t>01–05／06–10／14/15</a:t>
                       </a:r>
                     </a:p>
                   </a:txBody>
@@ -9157,7 +9416,7 @@
                           </a:solidFill>
                           <a:latin typeface="Yu Gothic"/>
                         </a:rPr>
-                        <a:t>TM商品・停止・発注期間が生鮮専用の可能性</a:t>
+                        <a:t>9/29判定では非生鮮と同じ</a:t>
                       </a:r>
                     </a:p>
                   </a:txBody>
@@ -9176,7 +9435,7 @@
                           </a:solidFill>
                           <a:latin typeface="Yu Gothic"/>
                         </a:rPr>
-                        <a:t>変換流用不可 → 別IF or 分岐</a:t>
+                        <a:t>流用。本体IFなし。B1で突合</a:t>
                       </a:r>
                     </a:p>
                   </a:txBody>
@@ -9197,7 +9456,7 @@
                           </a:solidFill>
                           <a:latin typeface="Yu Gothic"/>
                         </a:rPr>
-                        <a:t>03/04 カテゴリ・仕入先</a:t>
+                        <a:t>11 入荷実績</a:t>
                       </a:r>
                     </a:p>
                   </a:txBody>
@@ -9220,7 +9479,7 @@
                           </a:solidFill>
                           <a:latin typeface="Yu Gothic"/>
                         </a:rPr>
-                        <a:t>生鮮階層・仕入先体系が別</a:t>
+                        <a:t>伝票区分差分／PC・CK振替</a:t>
                       </a:r>
                     </a:p>
                   </a:txBody>
@@ -9243,7 +9502,7 @@
                           </a:solidFill>
                           <a:latin typeface="Yu Gothic"/>
                         </a:rPr>
-                        <a:t>コード体系の再マッピング</a:t>
+                        <a:t>差分IF（A）</a:t>
                       </a:r>
                     </a:p>
                   </a:txBody>
@@ -9268,7 +9527,7 @@
                           </a:solidFill>
                           <a:latin typeface="Yu Gothic"/>
                         </a:rPr>
-                        <a:t>05 ケースバラ</a:t>
+                        <a:t>12 入荷予定</a:t>
                       </a:r>
                     </a:p>
                   </a:txBody>
@@ -9287,7 +9546,7 @@
                           </a:solidFill>
                           <a:latin typeface="Yu Gothic"/>
                         </a:rPr>
-                        <a:t>計量・パック差</a:t>
+                        <a:t>ベンダー同じ／PC・CKは別SQL・DBGET</a:t>
                       </a:r>
                     </a:p>
                   </a:txBody>
@@ -9306,7 +9565,7 @@
                           </a:solidFill>
                           <a:latin typeface="Yu Gothic"/>
                         </a:rPr>
-                        <a:t>パターン追加</a:t>
+                        <a:t>差分IF（A）Layer①に加算</a:t>
                       </a:r>
                     </a:p>
                   </a:txBody>
@@ -9350,7 +9609,7 @@
                           </a:solidFill>
                           <a:latin typeface="Yu Gothic"/>
                         </a:rPr>
-                        <a:t>締め・便・曜日が別源</a:t>
+                        <a:t>ベンダー同じ／PC・CKは別SQL・DBGET</a:t>
                       </a:r>
                     </a:p>
                   </a:txBody>
@@ -9373,7 +9632,7 @@
                           </a:solidFill>
                           <a:latin typeface="Yu Gothic"/>
                         </a:rPr>
-                        <a:t>Layer①ソース分岐</a:t>
+                        <a:t>差分IF（A）Layer①に加算</a:t>
                       </a:r>
                     </a:p>
                   </a:txBody>
@@ -9398,7 +9657,7 @@
                           </a:solidFill>
                           <a:latin typeface="Yu Gothic"/>
                         </a:rPr>
-                        <a:t>14/15 棚割・新商品在庫</a:t>
+                        <a:t>24/25 勧告ファイル</a:t>
                       </a:r>
                     </a:p>
                   </a:txBody>
@@ -9417,7 +9676,7 @@
                           </a:solidFill>
                           <a:latin typeface="Yu Gothic"/>
                         </a:rPr>
-                        <a:t>店舗調達を使わない可能性</a:t>
+                        <a:t>2ファイル／1.5本換算</a:t>
                       </a:r>
                     </a:p>
                   </a:txBody>
@@ -9436,7 +9695,7 @@
                           </a:solidFill>
                           <a:latin typeface="Yu Gothic"/>
                         </a:rPr>
-                        <a:t>15個別対応／14ダミー可否</a:t>
+                        <a:t>S24=1本、S25=0.5本</a:t>
                       </a:r>
                     </a:p>
                   </a:txBody>
@@ -9457,7 +9716,7 @@
                           </a:solidFill>
                           <a:latin typeface="Yu Gothic"/>
                         </a:rPr>
-                        <a:t>06–10 実績・在庫</a:t>
+                        <a:t>勧告→発注統合</a:t>
                       </a:r>
                     </a:p>
                   </a:txBody>
@@ -9480,7 +9739,7 @@
                           </a:solidFill>
                           <a:latin typeface="Yu Gothic"/>
                         </a:rPr>
-                        <a:t>営業在庫の生鮮適用未検証</a:t>
+                        <a:t>現行生鮮IFは流用不可</a:t>
                       </a:r>
                     </a:p>
                   </a:txBody>
@@ -9503,7 +9762,7 @@
                           </a:solidFill>
                           <a:latin typeface="Yu Gothic"/>
                         </a:rPr>
-                        <a:t>計算前提の再確認</a:t>
+                        <a:t>新規IF（A）S26。参照は非生鮮24/25</a:t>
                       </a:r>
                     </a:p>
                   </a:txBody>
@@ -9512,6 +9771,65 @@
                       <a:srgbClr val="F5F8FB"/>
                     </a:solidFill>
                   </a:tcPr>
+                </a:tc>
+              </a:tr>
+              <a:tr h="292608">
+                <a:tc>
+                  <a:txBody>
+                    <a:bodyPr/>
+                    <a:lstStyle/>
+                    <a:p>
+                      <a:pPr algn="ctr"/>
+                      <a:r>
+                        <a:rPr sz="1200" b="0">
+                          <a:solidFill>
+                            <a:srgbClr val="2F2F2F"/>
+                          </a:solidFill>
+                          <a:latin typeface="Yu Gothic"/>
+                        </a:rPr>
+                        <a:t>倉庫系</a:t>
+                      </a:r>
+                    </a:p>
+                  </a:txBody>
+                  <a:tcPr anchor="ctr"/>
+                </a:tc>
+                <a:tc>
+                  <a:txBody>
+                    <a:bodyPr/>
+                    <a:lstStyle/>
+                    <a:p>
+                      <a:pPr algn="l"/>
+                      <a:r>
+                        <a:rPr sz="1200" b="0">
+                          <a:solidFill>
+                            <a:srgbClr val="2F2F2F"/>
+                          </a:solidFill>
+                          <a:latin typeface="Yu Gothic"/>
+                        </a:rPr>
+                        <a:t>DC在庫なし</a:t>
+                      </a:r>
+                    </a:p>
+                  </a:txBody>
+                  <a:tcPr anchor="ctr"/>
+                </a:tc>
+                <a:tc>
+                  <a:txBody>
+                    <a:bodyPr/>
+                    <a:lstStyle/>
+                    <a:p>
+                      <a:pPr algn="l"/>
+                      <a:r>
+                        <a:rPr sz="1200" b="0">
+                          <a:solidFill>
+                            <a:srgbClr val="2F2F2F"/>
+                          </a:solidFill>
+                          <a:latin typeface="Yu Gothic"/>
+                        </a:rPr>
+                        <a:t>対象外。水煮相当は午後MT</a:t>
+                      </a:r>
+                    </a:p>
+                  </a:txBody>
+                  <a:tcPr anchor="ctr"/>
                 </a:tc>
               </a:tr>
             </a:tbl>
@@ -9744,7 +10062,7 @@
                 </a:solidFill>
                 <a:latin typeface="Yu Gothic"/>
               </a:rPr>
-              <a:t>① B1 着手</a:t>
+              <a:t>① B1 突合</a:t>
             </a:r>
           </a:p>
           <a:p>
@@ -9763,8 +10081,8 @@
                 </a:solidFill>
                 <a:latin typeface="Yu Gothic"/>
               </a:rPr>
-              <a:t>A の Phase1 と並行
-マスタ一覧・三択判定</a:t>
+              <a:t>流用12本の突合
+倉庫対象外の整理</a:t>
             </a:r>
           </a:p>
         </p:txBody>
@@ -9820,7 +10138,7 @@
                 </a:solidFill>
                 <a:latin typeface="Yu Gothic"/>
               </a:rPr>
-              <a:t>② ゲート</a:t>
+              <a:t>② A 着手</a:t>
             </a:r>
           </a:p>
           <a:p>
@@ -9839,8 +10157,8 @@
                 </a:solidFill>
                 <a:latin typeface="Yu Gothic"/>
               </a:rPr>
-              <a:t>流用／差分／新規の
-本数を確定</a:t>
+              <a:t>差分／新規6本は
+マッピングから</a:t>
             </a:r>
           </a:p>
         </p:txBody>
@@ -9896,7 +10214,7 @@
                 </a:solidFill>
                 <a:latin typeface="Yu Gothic"/>
               </a:rPr>
-              <a:t>③ B2 置換</a:t>
+              <a:t>③ B2 維持</a:t>
             </a:r>
           </a:p>
           <a:p>
@@ -9915,8 +10233,8 @@
                 </a:solidFill>
                 <a:latin typeface="Yu Gothic"/>
               </a:rPr>
-              <a:t>仮置き51を
-確定値へ書き換え</a:t>
+              <a:t>本体IFは0のまま
+覆ったら再見積</a:t>
             </a:r>
           </a:p>
         </p:txBody>
@@ -9991,7 +10309,7 @@
                 </a:solidFill>
                 <a:latin typeface="Yu Gothic"/>
               </a:rPr>
-              <a:t>影響は B3 で吸収
+              <a:t>軽微は B3＝5
 超過なら再見積</a:t>
             </a:r>
           </a:p>
@@ -10067,7 +10385,7 @@
                 </a:solidFill>
                 <a:latin typeface="Yu Gothic"/>
               </a:rPr>
-              <a:t>・B1 判定で「新規／大幅差分」が本案の仮置き（≒3本）を明確に超える</a:t>
+              <a:t>・流用12本の一部が差分／新規に戻る</a:t>
             </a:r>
           </a:p>
           <a:p>
@@ -10086,7 +10404,7 @@
                 </a:solidFill>
                 <a:latin typeface="Yu Gothic"/>
               </a:rPr>
-              <a:t>・既存01–25のうち複数IFで再設計・再単体が必要（B3=15では足りない）</a:t>
+              <a:t>・倉庫商品マスタ（水煮相当）が要IF（午後MT）</a:t>
             </a:r>
           </a:p>
           <a:p>
@@ -10105,7 +10423,26 @@
                 </a:solidFill>
                 <a:latin typeface="Yu Gothic"/>
               </a:rPr>
-              <a:t>・GCSアップロード・生鮮側接続が想定より重い／連携先経路が会議前提から変わる</a:t>
+              <a:t>・GCSアップロード・接続が想定より重い／伝票区分差分が大きい</a:t>
+            </a:r>
+          </a:p>
+          <a:p>
+            <a:pPr algn="l">
+              <a:spcBef>
+                <a:spcPts val="500"/>
+              </a:spcBef>
+              <a:spcAft>
+                <a:spcPts val="200"/>
+              </a:spcAft>
+            </a:pPr>
+            <a:r>
+              <a:rPr sz="1300" b="0">
+                <a:solidFill>
+                  <a:srgbClr val="2F2F2F"/>
+                </a:solidFill>
+                <a:latin typeface="Yu Gothic"/>
+              </a:rPr>
+              <a:t>・S12/S13のSQL接続が重い、生鮮データの作成時刻が待ち合わせでは収まらない</a:t>
             </a:r>
           </a:p>
           <a:p>
@@ -10412,7 +10749,7 @@
                 </a:solidFill>
                 <a:latin typeface="Yu Gothic"/>
               </a:rPr>
-              <a:t>・先行トラン新規IF 4本</a:t>
+              <a:t>・先行トラン確定IF 6本</a:t>
             </a:r>
           </a:p>
           <a:p>
@@ -10431,7 +10768,7 @@
                 </a:solidFill>
                 <a:latin typeface="Yu Gothic"/>
               </a:rPr>
-              <a:t>・マスタ棚卸・判定（B1）</a:t>
+              <a:t>・流用突合・倉庫対象外整理（B1）</a:t>
             </a:r>
           </a:p>
           <a:p>
@@ -10450,7 +10787,7 @@
                 </a:solidFill>
                 <a:latin typeface="Yu Gothic"/>
               </a:rPr>
-              <a:t>・マスタIF仮置き（B2）と非生鮮Phase2波及（B3）</a:t>
+              <a:t>・マスタ本体IFは0（B2）。軽微波及（B3）</a:t>
             </a:r>
           </a:p>
           <a:p>
@@ -10639,7 +10976,7 @@
                 </a:solidFill>
                 <a:latin typeface="Yu Gothic"/>
               </a:rPr>
-              <a:t>・PMI課題 Sinops非生鮮のPhase2・共通基盤43・既存PJ50の契約変更</a:t>
+              <a:t>・倉庫系（DC在庫なし）</a:t>
             </a:r>
           </a:p>
           <a:p>
@@ -10658,7 +10995,7 @@
                 </a:solidFill>
                 <a:latin typeface="Yu Gothic"/>
               </a:rPr>
-              <a:t>・店舗系非生鮮Rの確定契約の読替え</a:t>
+              <a:t>・PMI課題 Sinops非生鮮のPhase2・共通基盤43・既存PJ50の契約変更</a:t>
             </a:r>
           </a:p>
         </p:txBody>

</xml_diff>

<commit_message>
docs: align seisen increment estimate Excel, PPT, and talk tracks
Keep A/B/C labels and 仮採番 in sync, and lead briefings with premises plus 再見積 triggers instead of slogan-style risk copy.

Co-authored-by: Cursor <cursoragent@cursor.com>
</commit_message>
<xml_diff>
--- a/PMI/Sinops/phase2-detail-design/sources/20260921-生鮮IF増分見積/【説明】生鮮IF増分_標準案見積_リスク着眼_20260921.pptx
+++ b/PMI/Sinops/phase2-detail-design/sources/20260921-生鮮IF増分見積/【説明】生鮮IF増分_標準案見積_リスク着眼_20260921.pptx
@@ -3214,7 +3214,7 @@
                 </a:solidFill>
                 <a:latin typeface="Yu Gothic"/>
               </a:rPr>
-              <a:t>生鮮 IF 増分見積　説明資料</a:t>
+              <a:t>生鮮IF増分見積　説明</a:t>
             </a:r>
           </a:p>
         </p:txBody>
@@ -3249,7 +3249,7 @@
                 </a:solidFill>
                 <a:latin typeface="Yu Gothic"/>
               </a:rPr>
-              <a:t>標準案｜調査・Mapping → 詳細設計・開発・単体（＋PJ按分）</a:t>
+              <a:t>標準案｜調査・Mapping〜詳細設計・開発・単体</a:t>
             </a:r>
           </a:p>
         </p:txBody>
@@ -3278,13 +3278,13 @@
           <a:p>
             <a:pPr algn="l"/>
             <a:r>
-              <a:rPr sz="1600" b="1">
+              <a:rPr sz="2000" b="1">
                 <a:solidFill>
                   <a:srgbClr val="FCE4D6"/>
                 </a:solidFill>
                 <a:latin typeface="Yu Gothic"/>
               </a:rPr>
-              <a:t>焦点：生鮮の不確実性を見積前提として明示し、提示値の読み方を揃える</a:t>
+              <a:t>160.5人日／¥5,120,000（税抜）</a:t>
             </a:r>
           </a:p>
         </p:txBody>
@@ -3319,7 +3319,7 @@
                 </a:solidFill>
                 <a:latin typeface="Yu Gothic"/>
               </a:rPr>
-              <a:t>西友 MD基幹統合　／　Sinops 自動補充 PMI</a:t>
+              <a:t>西友MD基幹統合　／　Sinops 自動補充 PMI</a:t>
             </a:r>
           </a:p>
           <a:p>
@@ -3338,7 +3338,7 @@
                 </a:solidFill>
                 <a:latin typeface="Yu Gothic"/>
               </a:rPr>
-              <a:t>資料日 2026-09-30（Rev.i）　出典：マスタデータ判定・標準案 Excel・20260918 生鮮IF会議</a:t>
+              <a:t>2026-09-30　出典：マスタデータ判定、標準案Excel、2026-09-18 生鮮IF会議</a:t>
             </a:r>
           </a:p>
         </p:txBody>
@@ -3408,7 +3408,7 @@
                 </a:solidFill>
                 <a:latin typeface="Yu Gothic"/>
               </a:rPr>
-              <a:t>9. 説明トーク（前提を先に言う）</a:t>
+              <a:t>9. 話し方</a:t>
             </a:r>
           </a:p>
         </p:txBody>
@@ -3443,7 +3443,7 @@
                 </a:solidFill>
                 <a:latin typeface="Yu Gothic"/>
               </a:rPr>
-              <a:t>数字の前に「不確実性の置き方」を置く。前提が崩れたら再見積。</a:t>
+              <a:t>数字の前に前提。崩れたら再見積。</a:t>
             </a:r>
           </a:p>
         </p:txBody>
@@ -3532,7 +3532,7 @@
                 </a:solidFill>
                 <a:latin typeface="Yu Gothic"/>
               </a:rPr>
-              <a:t>「生鮮は PMI課題 Sinops非生鮮のPhase2 の外の増分です。本日の提示は160.5人日／5,120,000円です。」</a:t>
+              <a:t>生鮮は非生鮮Phase2の外の増分。提示は160.5人日／512万円（税抜）。</a:t>
             </a:r>
           </a:p>
         </p:txBody>
@@ -3586,7 +3586,7 @@
                 </a:solidFill>
                 <a:latin typeface="Yu Gothic"/>
               </a:rPr>
-              <a:t>前提先出し</a:t>
+              <a:t>前提</a:t>
             </a:r>
           </a:p>
         </p:txBody>
@@ -3621,7 +3621,7 @@
                 </a:solidFill>
                 <a:latin typeface="Yu Gothic"/>
               </a:rPr>
-              <a:t>「提示値は 9/29 マスタデータの判定が成り立つ場合の工数で、確定請負ではありません。」</a:t>
+              <a:t>流用は先方協議の仮置き。当社未同席。確定請負ではない。</a:t>
             </a:r>
           </a:p>
         </p:txBody>
@@ -3710,7 +3710,7 @@
                 </a:solidFill>
                 <a:latin typeface="Yu Gothic"/>
               </a:rPr>
-              <a:t>「店舗系12本は流用。勧告2ファイルは1.5本換算。発注統合変換は新規。入荷とスケジュールは差分です。」</a:t>
+              <a:t>店舗系12本は流用前提でB1突合。勧告2ファイルは1.5本。発注統合変換は新規。入荷・日程は差分。</a:t>
             </a:r>
           </a:p>
         </p:txBody>
@@ -3764,7 +3764,7 @@
                 </a:solidFill>
                 <a:latin typeface="Yu Gothic"/>
               </a:rPr>
-              <a:t>本案の前提</a:t>
+              <a:t>覆り</a:t>
             </a:r>
           </a:p>
         </p:txBody>
@@ -3799,7 +3799,7 @@
                 </a:solidFill>
                 <a:latin typeface="Yu Gothic"/>
               </a:rPr>
-              <a:t>「判定が覆ったら、本日の数字は無効です。再見積です。」</a:t>
+              <a:t>流用が覆ったら本日の数字は無効。再見積。</a:t>
             </a:r>
           </a:p>
         </p:txBody>
@@ -3888,7 +3888,7 @@
                 </a:solidFill>
                 <a:latin typeface="Yu Gothic"/>
               </a:rPr>
-              <a:t>「マスタ本体IFは0です。水煮相当は午後MTの残件です。」</a:t>
+              <a:t>マスタ本体IFは0。水煮相当は午後MTの残件。</a:t>
             </a:r>
           </a:p>
         </p:txBody>
@@ -3977,7 +3977,7 @@
                 </a:solidFill>
                 <a:latin typeface="Yu Gothic"/>
               </a:rPr>
-              <a:t>「12本は突合、6本はマッピングから。B2は0のまま進めます。」</a:t>
+              <a:t>12本は突合、6本はMappingから。B2は0のまま。</a:t>
             </a:r>
           </a:p>
         </p:txBody>
@@ -4066,7 +4066,7 @@
                 </a:solidFill>
                 <a:latin typeface="Yu Gothic"/>
               </a:rPr>
-              <a:t>「Phase2は詳細設計・開発・単体まで。結合以降は含みません。」</a:t>
+              <a:t>Phase2は詳細設計・開発・単体まで。結合以降は含まない。</a:t>
             </a:r>
           </a:p>
         </p:txBody>
@@ -4101,7 +4101,7 @@
                 </a:solidFill>
                 <a:latin typeface="Yu Gothic"/>
               </a:rPr>
-              <a:t>西友MD基幹統合｜生鮮IF増分見積（標準案）説明｜2026-09-21 Rev.e</a:t>
+              <a:t>西友MD基幹統合｜生鮮IF増分見積｜2026-09-30</a:t>
             </a:r>
           </a:p>
         </p:txBody>
@@ -4213,42 +4213,7 @@
       </p:sp>
       <p:sp>
         <p:nvSpPr>
-          <p:cNvPr id="3" name="TextBox 2"/>
-          <p:cNvSpPr txBox="1"/>
-          <p:nvPr/>
-        </p:nvSpPr>
-        <p:spPr>
-          <a:xfrm>
-            <a:off x="320040" y="841248"/>
-            <a:ext cx="11430000" cy="320040"/>
-          </a:xfrm>
-          <a:prstGeom prst="rect">
-            <a:avLst/>
-          </a:prstGeom>
-          <a:noFill/>
-        </p:spPr>
-        <p:txBody>
-          <a:bodyPr wrap="none">
-            <a:spAutoFit/>
-          </a:bodyPr>
-          <a:lstStyle/>
-          <a:p>
-            <a:pPr algn="l"/>
-            <a:r>
-              <a:rPr sz="1200" b="0">
-                <a:solidFill>
-                  <a:srgbClr val="595959"/>
-                </a:solidFill>
-                <a:latin typeface="Yu Gothic"/>
-              </a:rPr>
-              <a:t>本案を説明するとき、必ず一緒に伝える3点</a:t>
-            </a:r>
-          </a:p>
-        </p:txBody>
-      </p:sp>
-      <p:sp>
-        <p:nvSpPr>
-          <p:cNvPr id="4" name="Rounded Rectangle 3"/>
+          <p:cNvPr id="3" name="Rounded Rectangle 2"/>
           <p:cNvSpPr/>
           <p:nvPr/>
         </p:nvSpPr>
@@ -4317,14 +4282,14 @@
                 <a:latin typeface="Yu Gothic"/>
               </a:rPr>
               <a:t>160.5人日／¥5,120,000（税抜）
-非生鮮Phase2（PMI課題）は据え置き</a:t>
-            </a:r>
-          </a:p>
-        </p:txBody>
-      </p:sp>
-      <p:sp>
-        <p:nvSpPr>
-          <p:cNvPr id="5" name="Rounded Rectangle 4"/>
+非生鮮Phase2は据え置き</a:t>
+            </a:r>
+          </a:p>
+        </p:txBody>
+      </p:sp>
+      <p:sp>
+        <p:nvSpPr>
+          <p:cNvPr id="4" name="Rounded Rectangle 3"/>
           <p:cNvSpPr/>
           <p:nvPr/>
         </p:nvSpPr>
@@ -4373,7 +4338,7 @@
                 </a:solidFill>
                 <a:latin typeface="Yu Gothic"/>
               </a:rPr>
-              <a:t>② 見積前提</a:t>
+              <a:t>② 前提</a:t>
             </a:r>
           </a:p>
           <a:p>
@@ -4392,15 +4357,15 @@
                 </a:solidFill>
                 <a:latin typeface="Yu Gothic"/>
               </a:rPr>
-              <a:t>9/29マスタデータ判定
-覆ったら再見積</a:t>
-            </a:r>
-          </a:p>
-        </p:txBody>
-      </p:sp>
-      <p:sp>
-        <p:nvSpPr>
-          <p:cNvPr id="6" name="Rounded Rectangle 5"/>
+              <a:t>先方協議の流用は未確認
+B1で突合。覆ったら再見積</a:t>
+            </a:r>
+          </a:p>
+        </p:txBody>
+      </p:sp>
+      <p:sp>
+        <p:nvSpPr>
+          <p:cNvPr id="5" name="Rounded Rectangle 4"/>
           <p:cNvSpPr/>
           <p:nvPr/>
         </p:nvSpPr>
@@ -4449,7 +4414,7 @@
                 </a:solidFill>
                 <a:latin typeface="Yu Gothic"/>
               </a:rPr>
-              <a:t>③ 運用条件</a:t>
+              <a:t>③ 進め方</a:t>
             </a:r>
           </a:p>
           <a:p>
@@ -4476,7 +4441,7 @@
       </p:sp>
       <p:sp>
         <p:nvSpPr>
-          <p:cNvPr id="7" name="Rounded Rectangle 6"/>
+          <p:cNvPr id="6" name="Rounded Rectangle 5"/>
           <p:cNvSpPr/>
           <p:nvPr/>
         </p:nvSpPr>
@@ -4589,7 +4554,7 @@
       </p:sp>
       <p:sp>
         <p:nvSpPr>
-          <p:cNvPr id="8" name="TextBox 7"/>
+          <p:cNvPr id="7" name="TextBox 6"/>
           <p:cNvSpPr txBox="1"/>
           <p:nvPr/>
         </p:nvSpPr>
@@ -4617,14 +4582,14 @@
                 </a:solidFill>
                 <a:latin typeface="Yu Gothic"/>
               </a:rPr>
-              <a:t>西友MD基幹統合｜生鮮IF増分見積（標準案）説明｜2026-09-21 Rev.e</a:t>
-            </a:r>
-          </a:p>
-        </p:txBody>
-      </p:sp>
-      <p:sp>
-        <p:nvSpPr>
-          <p:cNvPr id="9" name="TextBox 8"/>
+              <a:t>西友MD基幹統合｜生鮮IF増分見積｜2026-09-30</a:t>
+            </a:r>
+          </a:p>
+        </p:txBody>
+      </p:sp>
+      <p:sp>
+        <p:nvSpPr>
+          <p:cNvPr id="8" name="TextBox 7"/>
           <p:cNvSpPr txBox="1"/>
           <p:nvPr/>
         </p:nvSpPr>
@@ -4722,7 +4687,7 @@
                 </a:solidFill>
                 <a:latin typeface="Yu Gothic"/>
               </a:rPr>
-              <a:t>1. 結論（本見積の提示値）</a:t>
+              <a:t>1. 提示値</a:t>
             </a:r>
           </a:p>
         </p:txBody>
@@ -4757,7 +4722,7 @@
                 </a:solidFill>
                 <a:latin typeface="Yu Gothic"/>
               </a:rPr>
-              <a:t>PMI課題 Sinops非生鮮のPhase2は契約据え置き。本見積は生鮮増分のみ。</a:t>
+              <a:t>生鮮増分のみ。非生鮮Phase2の契約額は据え置き。</a:t>
             </a:r>
           </a:p>
         </p:txBody>
@@ -4813,7 +4778,7 @@
                 </a:solidFill>
                 <a:latin typeface="Yu Gothic"/>
               </a:rPr>
-              <a:t>人日合計</a:t>
+              <a:t>人日</a:t>
             </a:r>
           </a:p>
           <a:p>
@@ -4832,7 +4797,7 @@
                 </a:solidFill>
                 <a:latin typeface="Yu Gothic"/>
               </a:rPr>
-              <a:t>160.5 人日</a:t>
+              <a:t>160.5</a:t>
             </a:r>
           </a:p>
           <a:p>
@@ -4945,7 +4910,7 @@
                 </a:solidFill>
                 <a:latin typeface="Yu Gothic"/>
               </a:rPr>
-              <a:t>Phase1×40,000＋Phase2×27,500＋PJ×40,000</a:t>
+              <a:t>Phase1 4万／Phase2 2.75万／PJ 4万</a:t>
             </a:r>
           </a:p>
         </p:txBody>
@@ -5001,7 +4966,7 @@
                 </a:solidFill>
                 <a:latin typeface="Yu Gothic"/>
               </a:rPr>
-              <a:t>本見積の前提</a:t>
+              <a:t>前提</a:t>
             </a:r>
           </a:p>
           <a:p>
@@ -5020,7 +4985,7 @@
                 </a:solidFill>
                 <a:latin typeface="Yu Gothic"/>
               </a:rPr>
-              <a:t>本数は判定済み</a:t>
+              <a:t>流用は未確認</a:t>
             </a:r>
           </a:p>
           <a:p>
@@ -5039,8 +5004,7 @@
                 </a:solidFill>
                 <a:latin typeface="Yu Gothic"/>
               </a:rPr>
-              <a:t>12本流用・勧告1.5本
-S26新規・入荷は差分</a:t>
+              <a:t>先方協議の結果を仮置き。B1で突合</a:t>
             </a:r>
           </a:p>
         </p:txBody>
@@ -5096,7 +5060,7 @@
                 </a:solidFill>
                 <a:latin typeface="Yu Gothic"/>
               </a:rPr>
-              <a:t>説明時に最初に伝えること</a:t>
+              <a:t>先に伝えること</a:t>
             </a:r>
           </a:p>
           <a:p>
@@ -5115,7 +5079,7 @@
                 </a:solidFill>
                 <a:latin typeface="Yu Gothic"/>
               </a:rPr>
-              <a:t>・提示値は確定請負ではない。9/29判定が覆ったら再見積。</a:t>
+              <a:t>・確定請負ではない。突合で覆ったら再見積。</a:t>
             </a:r>
           </a:p>
           <a:p>
@@ -5134,7 +5098,7 @@
                 </a:solidFill>
                 <a:latin typeface="Yu Gothic"/>
               </a:rPr>
-              <a:t>・店舗系12本は流用。勧告2ファイルは1.5本換算。発注統合向け変換（S26）は新規。</a:t>
+              <a:t>・店舗系12本は先方協議では流用（当社未同席）。勧告2ファイルは1.5本。発注統合変換は新規。</a:t>
             </a:r>
           </a:p>
           <a:p>
@@ -5153,7 +5117,7 @@
                 </a:solidFill>
                 <a:latin typeface="Yu Gothic"/>
               </a:rPr>
-              <a:t>・B2（マスタIF本体）は0。倉庫はDC在庫なしで対象外。水煮相当は残件。</a:t>
+              <a:t>・B2は0。倉庫は対象外。水煮相当（倉庫商品マスタ）は残件。</a:t>
             </a:r>
           </a:p>
           <a:p>
@@ -5172,7 +5136,7 @@
                 </a:solidFill>
                 <a:latin typeface="Yu Gothic"/>
               </a:rPr>
-              <a:t>・PMI課題 Sinops非生鮮のPhase2の契約額は据え置き。</a:t>
+              <a:t>・非生鮮Phase2の契約額は動かさない。</a:t>
             </a:r>
           </a:p>
         </p:txBody>
@@ -5207,7 +5171,7 @@
                 </a:solidFill>
                 <a:latin typeface="Yu Gothic"/>
               </a:rPr>
-              <a:t>西友MD基幹統合｜生鮮IF増分見積（標準案）説明｜2026-09-21 Rev.e</a:t>
+              <a:t>西友MD基幹統合｜生鮮IF増分見積｜2026-09-30</a:t>
             </a:r>
           </a:p>
         </p:txBody>
@@ -5312,7 +5276,7 @@
                 </a:solidFill>
                 <a:latin typeface="Yu Gothic"/>
               </a:rPr>
-              <a:t>2. 見積前提条件（判定済みと残件・必読）</a:t>
+              <a:t>2. 前提</a:t>
             </a:r>
           </a:p>
         </p:txBody>
@@ -5347,7 +5311,7 @@
                 </a:solidFill>
                 <a:latin typeface="Yu Gothic"/>
               </a:rPr>
-              <a:t>マスタ本数は9/29判定済み。残るのは水煮・GCS・伝票区分・S26項目差・S12/S13のSQLと作成時刻。確定請負ではない。</a:t>
+              <a:t>店舗系12本は先方協議では流用。当社未同席。確定請負ではない。</a:t>
             </a:r>
           </a:p>
         </p:txBody>
@@ -5362,7 +5326,7 @@
         </p:nvGraphicFramePr>
         <p:xfrm>
           <a:off x="228600" y="1188720"/>
-          <a:ext cx="11795760" cy="2340864"/>
+          <a:ext cx="11795760" cy="2048256"/>
         </p:xfrm>
         <a:graphic>
           <a:graphicData uri="http://schemas.openxmlformats.org/drawingml/2006/table">
@@ -5412,7 +5376,7 @@
                           </a:solidFill>
                           <a:latin typeface="Yu Gothic"/>
                         </a:rPr>
-                        <a:t>前提として明示すること</a:t>
+                        <a:t>内容</a:t>
                       </a:r>
                     </a:p>
                   </a:txBody>
@@ -5435,7 +5399,7 @@
                           </a:solidFill>
                           <a:latin typeface="Yu Gothic"/>
                         </a:rPr>
-                        <a:t>見積上の扱い</a:t>
+                        <a:t>見積</a:t>
                       </a:r>
                     </a:p>
                   </a:txBody>
@@ -5479,7 +5443,7 @@
                           </a:solidFill>
                           <a:latin typeface="Yu Gothic"/>
                         </a:rPr>
-                        <a:t>9/29判定：店舗系12本は非生鮮と同じ（流用）</a:t>
+                        <a:t>先方協議では非生鮮と同じ。当社未同席</a:t>
                       </a:r>
                     </a:p>
                   </a:txBody>
@@ -5498,7 +5462,7 @@
                           </a:solidFill>
                           <a:latin typeface="Yu Gothic"/>
                         </a:rPr>
-                        <a:t>本体IFは置かない。B1は突合</a:t>
+                        <a:t>本体IFなし。B1で突合</a:t>
                       </a:r>
                     </a:p>
                   </a:txBody>
@@ -5519,7 +5483,7 @@
                           </a:solidFill>
                           <a:latin typeface="Yu Gothic"/>
                         </a:rPr>
-                        <a:t>横断影響</a:t>
+                        <a:t>波及</a:t>
                       </a:r>
                     </a:p>
                   </a:txBody>
@@ -5542,7 +5506,7 @@
                           </a:solidFill>
                           <a:latin typeface="Yu Gothic"/>
                         </a:rPr>
-                        <a:t>判定覆りは PMI課題 Sinops非生鮮のPhase2 にも波及し得る</a:t>
+                        <a:t>流用が覆ると非生鮮Phase2にも効き得る</a:t>
                       </a:r>
                     </a:p>
                   </a:txBody>
@@ -5565,7 +5529,7 @@
                           </a:solidFill>
                           <a:latin typeface="Yu Gothic"/>
                         </a:rPr>
-                        <a:t>B3に軽微バッファ。非生鮮Phase2契約額は据え置き</a:t>
+                        <a:t>B3に5人日。契約額は据え置き</a:t>
                       </a:r>
                     </a:p>
                   </a:txBody>
@@ -5590,7 +5554,7 @@
                           </a:solidFill>
                           <a:latin typeface="Yu Gothic"/>
                         </a:rPr>
-                        <a:t>源・GCS</a:t>
+                        <a:t>GCS</a:t>
                       </a:r>
                     </a:p>
                   </a:txBody>
@@ -5609,7 +5573,7 @@
                           </a:solidFill>
                           <a:latin typeface="Yu Gothic"/>
                         </a:rPr>
-                        <a:t>生鮮側サーバー→GCS。GCS無ければアップロードが必要（無い見込み）</a:t>
+                        <a:t>生鮮側サーバー→GCS。無い見込み</a:t>
                       </a:r>
                     </a:p>
                   </a:txBody>
@@ -5628,7 +5592,7 @@
                           </a:solidFill>
                           <a:latin typeface="Yu Gothic"/>
                         </a:rPr>
-                        <a:t>確認・アップロードを本見積に含む</a:t>
+                        <a:t>確認と必要時のアップロードを含む</a:t>
                       </a:r>
                     </a:p>
                   </a:txBody>
@@ -5649,7 +5613,7 @@
                           </a:solidFill>
                           <a:latin typeface="Yu Gothic"/>
                         </a:rPr>
-                        <a:t>入荷</a:t>
+                        <a:t>入荷・日程</a:t>
                       </a:r>
                     </a:p>
                   </a:txBody>
@@ -5672,7 +5636,7 @@
                           </a:solidFill>
                           <a:latin typeface="Yu Gothic"/>
                         </a:rPr>
-                        <a:t>ベンダー流用。実績＝伝票区分差分＋PC/CK振替。予定・日程＝PC/CKは別SQLでDBGET。作成時刻はやや不安定</a:t>
+                        <a:t>ベンダー流用。PC/CKは別SQLからDBGET</a:t>
                       </a:r>
                     </a:p>
                   </a:txBody>
@@ -5695,7 +5659,7 @@
                           </a:solidFill>
                           <a:latin typeface="Yu Gothic"/>
                         </a:rPr>
-                        <a:t>Aで差分IF。Layer①にDBGETと待ち合わせ</a:t>
+                        <a:t>Aの差分。Layer①に待ち合わせ</a:t>
                       </a:r>
                     </a:p>
                   </a:txBody>
@@ -5720,7 +5684,7 @@
                           </a:solidFill>
                           <a:latin typeface="Yu Gothic"/>
                         </a:rPr>
-                        <a:t>勧告の連携先</a:t>
+                        <a:t>勧告</a:t>
                       </a:r>
                     </a:p>
                   </a:txBody>
@@ -5739,7 +5703,7 @@
                           </a:solidFill>
                           <a:latin typeface="Yu Gothic"/>
                         </a:rPr>
-                        <a:t>現行生鮮→統合IFは流用不可。非生鮮24/25発注IFを参照して変換IFを新規</a:t>
+                        <a:t>現行の生鮮→統合IFは使わない</a:t>
                       </a:r>
                     </a:p>
                   </a:txBody>
@@ -5758,7 +5722,7 @@
                           </a:solidFill>
                           <a:latin typeface="Yu Gothic"/>
                         </a:rPr>
-                        <a:t>AでS26を計上</a:t>
+                        <a:t>Aで変換IFを新規</a:t>
                       </a:r>
                     </a:p>
                   </a:txBody>
@@ -5802,7 +5766,7 @@
                           </a:solidFill>
                           <a:latin typeface="Yu Gothic"/>
                         </a:rPr>
-                        <a:t>DC在庫なし。倉庫商品マスタ（水煮相当）は残件</a:t>
+                        <a:t>DC在庫なし。水煮相当は残件</a:t>
                       </a:r>
                     </a:p>
                   </a:txBody>
@@ -5825,7 +5789,7 @@
                           </a:solidFill>
                           <a:latin typeface="Yu Gothic"/>
                         </a:rPr>
-                        <a:t>倉庫系は対象外。要IFなら再見積</a:t>
+                        <a:t>対象外。要IFなら再見積</a:t>
                       </a:r>
                     </a:p>
                   </a:txBody>
@@ -5834,65 +5798,6 @@
                       <a:srgbClr val="F5F8FB"/>
                     </a:solidFill>
                   </a:tcPr>
-                </a:tc>
-              </a:tr>
-              <a:tr h="292608">
-                <a:tc>
-                  <a:txBody>
-                    <a:bodyPr/>
-                    <a:lstStyle/>
-                    <a:p>
-                      <a:pPr algn="ctr"/>
-                      <a:r>
-                        <a:rPr sz="1100" b="0">
-                          <a:solidFill>
-                            <a:srgbClr val="2F2F2F"/>
-                          </a:solidFill>
-                          <a:latin typeface="Yu Gothic"/>
-                        </a:rPr>
-                        <a:t>本案前提</a:t>
-                      </a:r>
-                    </a:p>
-                  </a:txBody>
-                  <a:tcPr anchor="ctr"/>
-                </a:tc>
-                <a:tc>
-                  <a:txBody>
-                    <a:bodyPr/>
-                    <a:lstStyle/>
-                    <a:p>
-                      <a:pPr algn="l"/>
-                      <a:r>
-                        <a:rPr sz="1100" b="0">
-                          <a:solidFill>
-                            <a:srgbClr val="2F2F2F"/>
-                          </a:solidFill>
-                          <a:latin typeface="Yu Gothic"/>
-                        </a:rPr>
-                        <a:t>9/29判定が成り立つ</a:t>
-                      </a:r>
-                    </a:p>
-                  </a:txBody>
-                  <a:tcPr anchor="ctr"/>
-                </a:tc>
-                <a:tc>
-                  <a:txBody>
-                    <a:bodyPr/>
-                    <a:lstStyle/>
-                    <a:p>
-                      <a:pPr algn="l"/>
-                      <a:r>
-                        <a:rPr sz="1100" b="0">
-                          <a:solidFill>
-                            <a:srgbClr val="2F2F2F"/>
-                          </a:solidFill>
-                          <a:latin typeface="Yu Gothic"/>
-                        </a:rPr>
-                        <a:t>この条件が崩れたら提示値は無効→再見積</a:t>
-                      </a:r>
-                    </a:p>
-                  </a:txBody>
-                  <a:tcPr anchor="ctr"/>
                 </a:tc>
               </a:tr>
             </a:tbl>
@@ -5929,7 +5834,7 @@
                 </a:solidFill>
                 <a:latin typeface="Yu Gothic"/>
               </a:rPr>
-              <a:t>Excel「見積前提条件・注記」シートに全文あり。説明時は本頁を数字より先に置く。</a:t>
+              <a:t>明細は Excel「見積前提条件」シート。</a:t>
             </a:r>
           </a:p>
         </p:txBody>
@@ -5964,7 +5869,7 @@
                 </a:solidFill>
                 <a:latin typeface="Yu Gothic"/>
               </a:rPr>
-              <a:t>西友MD基幹統合｜生鮮IF増分見積（標準案）説明｜2026-09-21 Rev.e</a:t>
+              <a:t>西友MD基幹統合｜生鮮IF増分見積｜2026-09-30</a:t>
             </a:r>
           </a:p>
         </p:txBody>
@@ -6069,7 +5974,7 @@
                 </a:solidFill>
                 <a:latin typeface="Yu Gothic"/>
               </a:rPr>
-              <a:t>3. 見積のブロック構成</a:t>
+              <a:t>3. ブロック構成</a:t>
             </a:r>
           </a:p>
         </p:txBody>
@@ -6104,7 +6009,7 @@
                 </a:solidFill>
                 <a:latin typeface="Yu Gothic"/>
               </a:rPr>
-              <a:t>A（確定IF）が本体。B2は0。S12/S13にDBGETを加算。</a:t>
+              <a:t>Aが本体。B2は0。入荷予定・発注スケジュールにDBGETを加算。</a:t>
             </a:r>
           </a:p>
         </p:txBody>
@@ -6128,11 +6033,11 @@
                 <a:tableStyleId>{5C22544A-7EE6-4342-B048-85BDC9FD1C3A}</a:tableStyleId>
               </a:tblPr>
               <a:tblGrid>
-                <a:gridCol w="640080"/>
-                <a:gridCol w="3291840"/>
-                <a:gridCol w="1188720"/>
-                <a:gridCol w="1645920"/>
-                <a:gridCol w="4572000"/>
+                <a:gridCol w="3108960"/>
+                <a:gridCol w="2560320"/>
+                <a:gridCol w="1005840"/>
+                <a:gridCol w="1463040"/>
+                <a:gridCol w="3200400"/>
               </a:tblGrid>
               <a:tr h="292608">
                 <a:tc>
@@ -6148,7 +6053,7 @@
                           </a:solidFill>
                           <a:latin typeface="Yu Gothic"/>
                         </a:rPr>
-                        <a:t>#</a:t>
+                        <a:t>ブロック</a:t>
                       </a:r>
                     </a:p>
                   </a:txBody>
@@ -6171,7 +6076,7 @@
                           </a:solidFill>
                           <a:latin typeface="Yu Gothic"/>
                         </a:rPr>
-                        <a:t>ブロック</a:t>
+                        <a:t>内訳</a:t>
                       </a:r>
                     </a:p>
                   </a:txBody>
@@ -6240,7 +6145,7 @@
                           </a:solidFill>
                           <a:latin typeface="Yu Gothic"/>
                         </a:rPr>
-                        <a:t>リスク感</a:t>
+                        <a:t>備考</a:t>
                       </a:r>
                     </a:p>
                   </a:txBody>
@@ -6265,7 +6170,7 @@
                           </a:solidFill>
                           <a:latin typeface="Yu Gothic"/>
                         </a:rPr>
-                        <a:t>A</a:t>
+                        <a:t>A（新規／差分IF）</a:t>
                       </a:r>
                     </a:p>
                   </a:txBody>
@@ -6284,7 +6189,7 @@
                           </a:solidFill>
                           <a:latin typeface="Yu Gothic"/>
                         </a:rPr>
-                        <a:t>確定IF（勧告1.5＋変換1＋入荷2＋日程1）</a:t>
+                        <a:t>勧告1.5＋変換1＋入荷2＋日程1</a:t>
                       </a:r>
                     </a:p>
                   </a:txBody>
@@ -6341,7 +6246,7 @@
                           </a:solidFill>
                           <a:latin typeface="Yu Gothic"/>
                         </a:rPr>
-                        <a:t>中（S12/S13にDBGET）</a:t>
+                        <a:t>入荷予定・発注スケジュールにDBGET</a:t>
                       </a:r>
                     </a:p>
                   </a:txBody>
@@ -6362,7 +6267,7 @@
                           </a:solidFill>
                           <a:latin typeface="Yu Gothic"/>
                         </a:rPr>
-                        <a:t>B1</a:t>
+                        <a:t>B1（流用確認・残件）</a:t>
                       </a:r>
                     </a:p>
                   </a:txBody>
@@ -6385,7 +6290,7 @@
                           </a:solidFill>
                           <a:latin typeface="Yu Gothic"/>
                         </a:rPr>
-                        <a:t>流用突合・倉庫対象外・GCS・残件</a:t>
+                        <a:t>突合・倉庫対象外・GCS・水煮</a:t>
                       </a:r>
                     </a:p>
                   </a:txBody>
@@ -6454,7 +6359,7 @@
                           </a:solidFill>
                           <a:latin typeface="Yu Gothic"/>
                         </a:rPr>
-                        <a:t>中（Phase1単価40,000）</a:t>
+                        <a:t>Phase1単価4万</a:t>
                       </a:r>
                     </a:p>
                   </a:txBody>
@@ -6479,7 +6384,7 @@
                           </a:solidFill>
                           <a:latin typeface="Yu Gothic"/>
                         </a:rPr>
-                        <a:t>B2</a:t>
+                        <a:t>B2（マスタ本体IF）</a:t>
                       </a:r>
                     </a:p>
                   </a:txBody>
@@ -6498,7 +6403,7 @@
                           </a:solidFill>
                           <a:latin typeface="Yu Gothic"/>
                         </a:rPr>
-                        <a:t>マスタIF本体</a:t>
+                        <a:t>先方協議では流用。当社未確認</a:t>
                       </a:r>
                     </a:p>
                   </a:txBody>
@@ -6555,7 +6460,7 @@
                           </a:solidFill>
                           <a:latin typeface="Yu Gothic"/>
                         </a:rPr>
-                        <a:t>流用確定のため0</a:t>
+                        <a:t>仮置き</a:t>
                       </a:r>
                     </a:p>
                   </a:txBody>
@@ -6576,7 +6481,7 @@
                           </a:solidFill>
                           <a:latin typeface="Yu Gothic"/>
                         </a:rPr>
-                        <a:t>B3</a:t>
+                        <a:t>B3（非生鮮Phase2波及）</a:t>
                       </a:r>
                     </a:p>
                   </a:txBody>
@@ -6599,7 +6504,7 @@
                           </a:solidFill>
                           <a:latin typeface="Yu Gothic"/>
                         </a:rPr>
-                        <a:t>非生鮮Phase2（PMI課題）への波及</a:t>
+                        <a:t>伝票区分・振替の軽微注記</a:t>
                       </a:r>
                     </a:p>
                   </a:txBody>
@@ -6668,7 +6573,7 @@
                           </a:solidFill>
                           <a:latin typeface="Yu Gothic"/>
                         </a:rPr>
-                        <a:t>低（Phase2直接27,500）</a:t>
+                        <a:t>Phase2直接2.75万</a:t>
                       </a:r>
                     </a:p>
                   </a:txBody>
@@ -6686,6 +6591,16 @@
                     <a:lstStyle/>
                     <a:p>
                       <a:pPr algn="ctr"/>
+                    </a:p>
+                  </a:txBody>
+                  <a:tcPr anchor="ctr"/>
+                </a:tc>
+                <a:tc>
+                  <a:txBody>
+                    <a:bodyPr/>
+                    <a:lstStyle/>
+                    <a:p>
+                      <a:pPr algn="l"/>
                       <a:r>
                         <a:rPr sz="1200" b="0">
                           <a:solidFill>
@@ -6693,26 +6608,7 @@
                           </a:solidFill>
                           <a:latin typeface="Yu Gothic"/>
                         </a:rPr>
-                        <a:t>—</a:t>
-                      </a:r>
-                    </a:p>
-                  </a:txBody>
-                  <a:tcPr anchor="ctr"/>
-                </a:tc>
-                <a:tc>
-                  <a:txBody>
-                    <a:bodyPr/>
-                    <a:lstStyle/>
-                    <a:p>
-                      <a:pPr algn="l"/>
-                      <a:r>
-                        <a:rPr sz="1200" b="0">
-                          <a:solidFill>
-                            <a:srgbClr val="2F2F2F"/>
-                          </a:solidFill>
-                          <a:latin typeface="Yu Gothic"/>
-                        </a:rPr>
-                        <a:t>直接小計</a:t>
+                        <a:t>直接小計（A＋B1＋B2＋B3）</a:t>
                       </a:r>
                     </a:p>
                   </a:txBody>
@@ -6781,7 +6677,7 @@
                           </a:solidFill>
                           <a:latin typeface="Yu Gothic"/>
                         </a:rPr>
-                        <a:t>C</a:t>
+                        <a:t>C（PJ管理按分）</a:t>
                       </a:r>
                     </a:p>
                   </a:txBody>
@@ -6804,7 +6700,7 @@
                           </a:solidFill>
                           <a:latin typeface="Yu Gothic"/>
                         </a:rPr>
-                        <a:t>PJ管理（按分）</a:t>
+                        <a:t>直接×50／499.5</a:t>
                       </a:r>
                     </a:p>
                   </a:txBody>
@@ -6873,7 +6769,7 @@
                           </a:solidFill>
                           <a:latin typeface="Yu Gothic"/>
                         </a:rPr>
-                        <a:t>既存比率 50/499.5</a:t>
+                        <a:t>既存比率</a:t>
                       </a:r>
                     </a:p>
                   </a:txBody>
@@ -6891,6 +6787,16 @@
                     <a:lstStyle/>
                     <a:p>
                       <a:pPr algn="ctr"/>
+                    </a:p>
+                  </a:txBody>
+                  <a:tcPr anchor="ctr"/>
+                </a:tc>
+                <a:tc>
+                  <a:txBody>
+                    <a:bodyPr/>
+                    <a:lstStyle/>
+                    <a:p>
+                      <a:pPr algn="l"/>
                       <a:r>
                         <a:rPr sz="1200" b="0">
                           <a:solidFill>
@@ -6902,11 +6808,7 @@
                       </a:r>
                     </a:p>
                   </a:txBody>
-                  <a:tcPr anchor="ctr">
-                    <a:solidFill>
-                      <a:srgbClr val="E2F0D9"/>
-                    </a:solidFill>
-                  </a:tcPr>
+                  <a:tcPr anchor="ctr"/>
                 </a:tc>
                 <a:tc>
                   <a:txBody>
@@ -6921,15 +6823,11 @@
                           </a:solidFill>
                           <a:latin typeface="Yu Gothic"/>
                         </a:rPr>
-                        <a:t>本見積</a:t>
-                      </a:r>
-                    </a:p>
-                  </a:txBody>
-                  <a:tcPr anchor="ctr">
-                    <a:solidFill>
-                      <a:srgbClr val="E2F0D9"/>
-                    </a:solidFill>
-                  </a:tcPr>
+                        <a:t>160.5</a:t>
+                      </a:r>
+                    </a:p>
+                  </a:txBody>
+                  <a:tcPr anchor="ctr"/>
                 </a:tc>
                 <a:tc>
                   <a:txBody>
@@ -6944,15 +6842,11 @@
                           </a:solidFill>
                           <a:latin typeface="Yu Gothic"/>
                         </a:rPr>
-                        <a:t>160.5</a:t>
-                      </a:r>
-                    </a:p>
-                  </a:txBody>
-                  <a:tcPr anchor="ctr">
-                    <a:solidFill>
-                      <a:srgbClr val="E2F0D9"/>
-                    </a:solidFill>
-                  </a:tcPr>
+                        <a:t>5,120,000</a:t>
+                      </a:r>
+                    </a:p>
+                  </a:txBody>
+                  <a:tcPr anchor="ctr"/>
                 </a:tc>
                 <a:tc>
                   <a:txBody>
@@ -6960,36 +6854,9 @@
                     <a:lstStyle/>
                     <a:p>
                       <a:pPr algn="l"/>
-                      <a:r>
-                        <a:rPr sz="1200" b="0">
-                          <a:solidFill>
-                            <a:srgbClr val="2F2F2F"/>
-                          </a:solidFill>
-                          <a:latin typeface="Yu Gothic"/>
-                        </a:rPr>
-                        <a:t>5,120,000</a:t>
-                      </a:r>
-                    </a:p>
-                  </a:txBody>
-                  <a:tcPr anchor="ctr">
-                    <a:solidFill>
-                      <a:srgbClr val="E2F0D9"/>
-                    </a:solidFill>
-                  </a:tcPr>
-                </a:tc>
-                <a:tc>
-                  <a:txBody>
-                    <a:bodyPr/>
-                    <a:lstStyle/>
-                    <a:p>
-                      <a:pPr algn="l"/>
-                    </a:p>
-                  </a:txBody>
-                  <a:tcPr anchor="ctr">
-                    <a:solidFill>
-                      <a:srgbClr val="E2F0D9"/>
-                    </a:solidFill>
-                  </a:tcPr>
+                    </a:p>
+                  </a:txBody>
+                  <a:tcPr anchor="ctr"/>
                 </a:tc>
               </a:tr>
             </a:tbl>
@@ -7020,13 +6887,13 @@
           <a:p>
             <a:pPr algn="l"/>
             <a:r>
-              <a:rPr sz="1300" b="1">
-                <a:solidFill>
-                  <a:srgbClr val="C65911"/>
-                </a:solidFill>
-                <a:latin typeface="Yu Gothic"/>
-              </a:rPr>
-              <a:t>オレンジ相当の B1〜B3 が「見積リスクを数値化した場所」。A だけ見せるとリスクを過小評価する。</a:t>
+              <a:rPr sz="1300" b="0">
+                <a:solidFill>
+                  <a:srgbClr val="2F2F2F"/>
+                </a:solidFill>
+                <a:latin typeface="Yu Gothic"/>
+              </a:rPr>
+              <a:t>B1〜B3は確認・残件・波及。Aだけ見せると残件が見えない。</a:t>
             </a:r>
           </a:p>
         </p:txBody>
@@ -7061,7 +6928,7 @@
                 </a:solidFill>
                 <a:latin typeface="Yu Gothic"/>
               </a:rPr>
-              <a:t>西友MD基幹統合｜生鮮IF増分見積（標準案）説明｜2026-09-21 Rev.e</a:t>
+              <a:t>西友MD基幹統合｜生鮮IF増分見積｜2026-09-30</a:t>
             </a:r>
           </a:p>
         </p:txBody>
@@ -7166,7 +7033,7 @@
                 </a:solidFill>
                 <a:latin typeface="Yu Gothic"/>
               </a:rPr>
-              <a:t>4. A｜確定IF（勧告は1.5本換算）</a:t>
+              <a:t>4. A（新規／差分IF）｜勧告は1.5本</a:t>
             </a:r>
           </a:p>
         </p:txBody>
@@ -7201,7 +7068,7 @@
                 </a:solidFill>
                 <a:latin typeface="Yu Gothic"/>
               </a:rPr>
-              <a:t>当日1本＋翌日0.5本。発注統合変換は別1本。入荷・スケジュールは差分</a:t>
+              <a:t>当日1本＋翌日0.5本。発注統合変換は別1本。入荷・日程は差分。S番号は仮採番。</a:t>
             </a:r>
           </a:p>
         </p:txBody>
@@ -7225,13 +7092,12 @@
                 <a:tableStyleId>{5C22544A-7EE6-4342-B048-85BDC9FD1C3A}</a:tableStyleId>
               </a:tblPr>
               <a:tblGrid>
-                <a:gridCol w="2194560"/>
+                <a:gridCol w="3657600"/>
                 <a:gridCol w="914400"/>
-                <a:gridCol w="822960"/>
-                <a:gridCol w="822960"/>
-                <a:gridCol w="822960"/>
                 <a:gridCol w="914400"/>
-                <a:gridCol w="5029200"/>
+                <a:gridCol w="914400"/>
+                <a:gridCol w="914400"/>
+                <a:gridCol w="4206240"/>
               </a:tblGrid>
               <a:tr h="292608">
                 <a:tc>
@@ -7270,7 +7136,7 @@
                           </a:solidFill>
                           <a:latin typeface="Yu Gothic"/>
                         </a:rPr>
-                        <a:t>仮No.</a:t>
+                        <a:t>Phase1</a:t>
                       </a:r>
                     </a:p>
                   </a:txBody>
@@ -7293,7 +7159,7 @@
                           </a:solidFill>
                           <a:latin typeface="Yu Gothic"/>
                         </a:rPr>
-                        <a:t>Phase1</a:t>
+                        <a:t>Layer①</a:t>
                       </a:r>
                     </a:p>
                   </a:txBody>
@@ -7316,7 +7182,7 @@
                           </a:solidFill>
                           <a:latin typeface="Yu Gothic"/>
                         </a:rPr>
-                        <a:t>Layer①</a:t>
+                        <a:t>Layer③</a:t>
                       </a:r>
                     </a:p>
                   </a:txBody>
@@ -7339,7 +7205,7 @@
                           </a:solidFill>
                           <a:latin typeface="Yu Gothic"/>
                         </a:rPr>
-                        <a:t>Layer③</a:t>
+                        <a:t>計</a:t>
                       </a:r>
                     </a:p>
                   </a:txBody>
@@ -7362,7 +7228,7 @@
                           </a:solidFill>
                           <a:latin typeface="Yu Gothic"/>
                         </a:rPr>
-                        <a:t>計</a:t>
+                        <a:t>備考</a:t>
                       </a:r>
                     </a:p>
                   </a:txBody>
@@ -7372,29 +7238,6 @@
                     </a:solidFill>
                   </a:tcPr>
                 </a:tc>
-                <a:tc>
-                  <a:txBody>
-                    <a:bodyPr/>
-                    <a:lstStyle/>
-                    <a:p>
-                      <a:pPr algn="l"/>
-                      <a:r>
-                        <a:rPr sz="1100" b="1">
-                          <a:solidFill>
-                            <a:srgbClr val="FFFFFF"/>
-                          </a:solidFill>
-                          <a:latin typeface="Yu Gothic"/>
-                        </a:rPr>
-                        <a:t>なぜ置くか</a:t>
-                      </a:r>
-                    </a:p>
-                  </a:txBody>
-                  <a:tcPr anchor="ctr">
-                    <a:solidFill>
-                      <a:srgbClr val="1F4E78"/>
-                    </a:solidFill>
-                  </a:tcPr>
-                </a:tc>
               </a:tr>
               <a:tr h="292608">
                 <a:tc>
@@ -7410,7 +7253,7 @@
                           </a:solidFill>
                           <a:latin typeface="Yu Gothic"/>
                         </a:rPr>
-                        <a:t>発注勧告（当日）</a:t>
+                        <a:t>発注勧告（当日）S24（仮採番）</a:t>
                       </a:r>
                     </a:p>
                   </a:txBody>
@@ -7429,7 +7272,7 @@
                           </a:solidFill>
                           <a:latin typeface="Yu Gothic"/>
                         </a:rPr>
-                        <a:t>S24</a:t>
+                        <a:t>5.0</a:t>
                       </a:r>
                     </a:p>
                   </a:txBody>
@@ -7448,7 +7291,7 @@
                           </a:solidFill>
                           <a:latin typeface="Yu Gothic"/>
                         </a:rPr>
-                        <a:t>5.0</a:t>
+                        <a:t>17.0</a:t>
                       </a:r>
                     </a:p>
                   </a:txBody>
@@ -7467,7 +7310,7 @@
                           </a:solidFill>
                           <a:latin typeface="Yu Gothic"/>
                         </a:rPr>
-                        <a:t>17.0</a:t>
+                        <a:t>4.5</a:t>
                       </a:r>
                     </a:p>
                   </a:txBody>
@@ -7486,7 +7329,7 @@
                           </a:solidFill>
                           <a:latin typeface="Yu Gothic"/>
                         </a:rPr>
-                        <a:t>4.5</a:t>
+                        <a:t>26.5</a:t>
                       </a:r>
                     </a:p>
                   </a:txBody>
@@ -7505,26 +7348,7 @@
                           </a:solidFill>
                           <a:latin typeface="Yu Gothic"/>
                         </a:rPr>
-                        <a:t>26.5</a:t>
-                      </a:r>
-                    </a:p>
-                  </a:txBody>
-                  <a:tcPr anchor="ctr"/>
-                </a:tc>
-                <a:tc>
-                  <a:txBody>
-                    <a:bodyPr/>
-                    <a:lstStyle/>
-                    <a:p>
-                      <a:pPr algn="l"/>
-                      <a:r>
-                        <a:rPr sz="1100" b="0">
-                          <a:solidFill>
-                            <a:srgbClr val="2F2F2F"/>
-                          </a:solidFill>
-                          <a:latin typeface="Yu Gothic"/>
-                        </a:rPr>
-                        <a:t>Sinops勧告。1.0本</a:t>
+                        <a:t>1.0本</a:t>
                       </a:r>
                     </a:p>
                   </a:txBody>
@@ -7545,7 +7369,7 @@
                           </a:solidFill>
                           <a:latin typeface="Yu Gothic"/>
                         </a:rPr>
-                        <a:t>発注勧告（翌日以降）</a:t>
+                        <a:t>発注勧告（翌日以降）S25（仮採番）</a:t>
                       </a:r>
                     </a:p>
                   </a:txBody>
@@ -7568,7 +7392,7 @@
                           </a:solidFill>
                           <a:latin typeface="Yu Gothic"/>
                         </a:rPr>
-                        <a:t>S25</a:t>
+                        <a:t>2.5</a:t>
                       </a:r>
                     </a:p>
                   </a:txBody>
@@ -7591,7 +7415,7 @@
                           </a:solidFill>
                           <a:latin typeface="Yu Gothic"/>
                         </a:rPr>
-                        <a:t>2.5</a:t>
+                        <a:t>8.5</a:t>
                       </a:r>
                     </a:p>
                   </a:txBody>
@@ -7614,7 +7438,7 @@
                           </a:solidFill>
                           <a:latin typeface="Yu Gothic"/>
                         </a:rPr>
-                        <a:t>8.5</a:t>
+                        <a:t>2.5</a:t>
                       </a:r>
                     </a:p>
                   </a:txBody>
@@ -7637,7 +7461,7 @@
                           </a:solidFill>
                           <a:latin typeface="Yu Gothic"/>
                         </a:rPr>
-                        <a:t>2.5</a:t>
+                        <a:t>13.5</a:t>
                       </a:r>
                     </a:p>
                   </a:txBody>
@@ -7660,7 +7484,7 @@
                           </a:solidFill>
                           <a:latin typeface="Yu Gothic"/>
                         </a:rPr>
-                        <a:t>13.5</a:t>
+                        <a:t>当日類似。0.5本</a:t>
                       </a:r>
                     </a:p>
                   </a:txBody>
@@ -7670,6 +7494,27 @@
                     </a:solidFill>
                   </a:tcPr>
                 </a:tc>
+              </a:tr>
+              <a:tr h="292608">
+                <a:tc>
+                  <a:txBody>
+                    <a:bodyPr/>
+                    <a:lstStyle/>
+                    <a:p>
+                      <a:pPr algn="ctr"/>
+                      <a:r>
+                        <a:rPr sz="1100" b="0">
+                          <a:solidFill>
+                            <a:srgbClr val="2F2F2F"/>
+                          </a:solidFill>
+                          <a:latin typeface="Yu Gothic"/>
+                        </a:rPr>
+                        <a:t>勧告→発注統合変換 S26（仮採番）</a:t>
+                      </a:r>
+                    </a:p>
+                  </a:txBody>
+                  <a:tcPr anchor="ctr"/>
+                </a:tc>
                 <a:tc>
                   <a:txBody>
                     <a:bodyPr/>
@@ -7683,7 +7528,104 @@
                           </a:solidFill>
                           <a:latin typeface="Yu Gothic"/>
                         </a:rPr>
-                        <a:t>当日類似。0.5本換算</a:t>
+                        <a:t>5.0</a:t>
+                      </a:r>
+                    </a:p>
+                  </a:txBody>
+                  <a:tcPr anchor="ctr"/>
+                </a:tc>
+                <a:tc>
+                  <a:txBody>
+                    <a:bodyPr/>
+                    <a:lstStyle/>
+                    <a:p>
+                      <a:pPr algn="l"/>
+                      <a:r>
+                        <a:rPr sz="1100" b="0">
+                          <a:solidFill>
+                            <a:srgbClr val="2F2F2F"/>
+                          </a:solidFill>
+                          <a:latin typeface="Yu Gothic"/>
+                        </a:rPr>
+                        <a:t>14.0</a:t>
+                      </a:r>
+                    </a:p>
+                  </a:txBody>
+                  <a:tcPr anchor="ctr"/>
+                </a:tc>
+                <a:tc>
+                  <a:txBody>
+                    <a:bodyPr/>
+                    <a:lstStyle/>
+                    <a:p>
+                      <a:pPr algn="l"/>
+                      <a:r>
+                        <a:rPr sz="1100" b="0">
+                          <a:solidFill>
+                            <a:srgbClr val="2F2F2F"/>
+                          </a:solidFill>
+                          <a:latin typeface="Yu Gothic"/>
+                        </a:rPr>
+                        <a:t>3.0</a:t>
+                      </a:r>
+                    </a:p>
+                  </a:txBody>
+                  <a:tcPr anchor="ctr"/>
+                </a:tc>
+                <a:tc>
+                  <a:txBody>
+                    <a:bodyPr/>
+                    <a:lstStyle/>
+                    <a:p>
+                      <a:pPr algn="l"/>
+                      <a:r>
+                        <a:rPr sz="1100" b="0">
+                          <a:solidFill>
+                            <a:srgbClr val="2F2F2F"/>
+                          </a:solidFill>
+                          <a:latin typeface="Yu Gothic"/>
+                        </a:rPr>
+                        <a:t>22.0</a:t>
+                      </a:r>
+                    </a:p>
+                  </a:txBody>
+                  <a:tcPr anchor="ctr"/>
+                </a:tc>
+                <a:tc>
+                  <a:txBody>
+                    <a:bodyPr/>
+                    <a:lstStyle/>
+                    <a:p>
+                      <a:pPr algn="l"/>
+                      <a:r>
+                        <a:rPr sz="1100" b="0">
+                          <a:solidFill>
+                            <a:srgbClr val="2F2F2F"/>
+                          </a:solidFill>
+                          <a:latin typeface="Yu Gothic"/>
+                        </a:rPr>
+                        <a:t>現行生鮮→統合IFは使わない</a:t>
+                      </a:r>
+                    </a:p>
+                  </a:txBody>
+                  <a:tcPr anchor="ctr"/>
+                </a:tc>
+              </a:tr>
+              <a:tr h="292608">
+                <a:tc>
+                  <a:txBody>
+                    <a:bodyPr/>
+                    <a:lstStyle/>
+                    <a:p>
+                      <a:pPr algn="ctr"/>
+                      <a:r>
+                        <a:rPr sz="1100" b="0">
+                          <a:solidFill>
+                            <a:srgbClr val="2F2F2F"/>
+                          </a:solidFill>
+                          <a:latin typeface="Yu Gothic"/>
+                        </a:rPr>
+                        <a:t>入荷実績 S11（仮採番）</a:t>
                       </a:r>
                     </a:p>
                   </a:txBody>
@@ -7693,14 +7635,12 @@
                     </a:solidFill>
                   </a:tcPr>
                 </a:tc>
-              </a:tr>
-              <a:tr h="292608">
-                <a:tc>
-                  <a:txBody>
-                    <a:bodyPr/>
-                    <a:lstStyle/>
-                    <a:p>
-                      <a:pPr algn="ctr"/>
+                <a:tc>
+                  <a:txBody>
+                    <a:bodyPr/>
+                    <a:lstStyle/>
+                    <a:p>
+                      <a:pPr algn="l"/>
                       <a:r>
                         <a:rPr sz="1100" b="0">
                           <a:solidFill>
@@ -7708,142 +7648,7 @@
                           </a:solidFill>
                           <a:latin typeface="Yu Gothic"/>
                         </a:rPr>
-                        <a:t>勧告→発注統合変換</a:t>
-                      </a:r>
-                    </a:p>
-                  </a:txBody>
-                  <a:tcPr anchor="ctr"/>
-                </a:tc>
-                <a:tc>
-                  <a:txBody>
-                    <a:bodyPr/>
-                    <a:lstStyle/>
-                    <a:p>
-                      <a:pPr algn="l"/>
-                      <a:r>
-                        <a:rPr sz="1100" b="0">
-                          <a:solidFill>
-                            <a:srgbClr val="2F2F2F"/>
-                          </a:solidFill>
-                          <a:latin typeface="Yu Gothic"/>
-                        </a:rPr>
-                        <a:t>S26</a:t>
-                      </a:r>
-                    </a:p>
-                  </a:txBody>
-                  <a:tcPr anchor="ctr"/>
-                </a:tc>
-                <a:tc>
-                  <a:txBody>
-                    <a:bodyPr/>
-                    <a:lstStyle/>
-                    <a:p>
-                      <a:pPr algn="l"/>
-                      <a:r>
-                        <a:rPr sz="1100" b="0">
-                          <a:solidFill>
-                            <a:srgbClr val="2F2F2F"/>
-                          </a:solidFill>
-                          <a:latin typeface="Yu Gothic"/>
-                        </a:rPr>
-                        <a:t>5.0</a:t>
-                      </a:r>
-                    </a:p>
-                  </a:txBody>
-                  <a:tcPr anchor="ctr"/>
-                </a:tc>
-                <a:tc>
-                  <a:txBody>
-                    <a:bodyPr/>
-                    <a:lstStyle/>
-                    <a:p>
-                      <a:pPr algn="l"/>
-                      <a:r>
-                        <a:rPr sz="1100" b="0">
-                          <a:solidFill>
-                            <a:srgbClr val="2F2F2F"/>
-                          </a:solidFill>
-                          <a:latin typeface="Yu Gothic"/>
-                        </a:rPr>
-                        <a:t>14.0</a:t>
-                      </a:r>
-                    </a:p>
-                  </a:txBody>
-                  <a:tcPr anchor="ctr"/>
-                </a:tc>
-                <a:tc>
-                  <a:txBody>
-                    <a:bodyPr/>
-                    <a:lstStyle/>
-                    <a:p>
-                      <a:pPr algn="l"/>
-                      <a:r>
-                        <a:rPr sz="1100" b="0">
-                          <a:solidFill>
-                            <a:srgbClr val="2F2F2F"/>
-                          </a:solidFill>
-                          <a:latin typeface="Yu Gothic"/>
-                        </a:rPr>
-                        <a:t>3.0</a:t>
-                      </a:r>
-                    </a:p>
-                  </a:txBody>
-                  <a:tcPr anchor="ctr"/>
-                </a:tc>
-                <a:tc>
-                  <a:txBody>
-                    <a:bodyPr/>
-                    <a:lstStyle/>
-                    <a:p>
-                      <a:pPr algn="l"/>
-                      <a:r>
-                        <a:rPr sz="1100" b="0">
-                          <a:solidFill>
-                            <a:srgbClr val="2F2F2F"/>
-                          </a:solidFill>
-                          <a:latin typeface="Yu Gothic"/>
-                        </a:rPr>
-                        <a:t>22.0</a:t>
-                      </a:r>
-                    </a:p>
-                  </a:txBody>
-                  <a:tcPr anchor="ctr"/>
-                </a:tc>
-                <a:tc>
-                  <a:txBody>
-                    <a:bodyPr/>
-                    <a:lstStyle/>
-                    <a:p>
-                      <a:pPr algn="l"/>
-                      <a:r>
-                        <a:rPr sz="1100" b="0">
-                          <a:solidFill>
-                            <a:srgbClr val="2F2F2F"/>
-                          </a:solidFill>
-                          <a:latin typeface="Yu Gothic"/>
-                        </a:rPr>
-                        <a:t>現行生鮮→統合IFは使わない。非生鮮24/25参照</a:t>
-                      </a:r>
-                    </a:p>
-                  </a:txBody>
-                  <a:tcPr anchor="ctr"/>
-                </a:tc>
-              </a:tr>
-              <a:tr h="292608">
-                <a:tc>
-                  <a:txBody>
-                    <a:bodyPr/>
-                    <a:lstStyle/>
-                    <a:p>
-                      <a:pPr algn="ctr"/>
-                      <a:r>
-                        <a:rPr sz="1100" b="0">
-                          <a:solidFill>
-                            <a:srgbClr val="2F2F2F"/>
-                          </a:solidFill>
-                          <a:latin typeface="Yu Gothic"/>
-                        </a:rPr>
-                        <a:t>入荷実績</a:t>
+                        <a:t>4.0</a:t>
                       </a:r>
                     </a:p>
                   </a:txBody>
@@ -7866,7 +7671,7 @@
                           </a:solidFill>
                           <a:latin typeface="Yu Gothic"/>
                         </a:rPr>
-                        <a:t>S11</a:t>
+                        <a:t>12.0</a:t>
                       </a:r>
                     </a:p>
                   </a:txBody>
@@ -7889,7 +7694,7 @@
                           </a:solidFill>
                           <a:latin typeface="Yu Gothic"/>
                         </a:rPr>
-                        <a:t>4.0</a:t>
+                        <a:t>2.5</a:t>
                       </a:r>
                     </a:p>
                   </a:txBody>
@@ -7912,7 +7717,7 @@
                           </a:solidFill>
                           <a:latin typeface="Yu Gothic"/>
                         </a:rPr>
-                        <a:t>12.0</a:t>
+                        <a:t>18.5</a:t>
                       </a:r>
                     </a:p>
                   </a:txBody>
@@ -7935,7 +7740,7 @@
                           </a:solidFill>
                           <a:latin typeface="Yu Gothic"/>
                         </a:rPr>
-                        <a:t>2.5</a:t>
+                        <a:t>伝票区分差分＋PC/CK振替</a:t>
                       </a:r>
                     </a:p>
                   </a:txBody>
@@ -7945,6 +7750,27 @@
                     </a:solidFill>
                   </a:tcPr>
                 </a:tc>
+              </a:tr>
+              <a:tr h="292608">
+                <a:tc>
+                  <a:txBody>
+                    <a:bodyPr/>
+                    <a:lstStyle/>
+                    <a:p>
+                      <a:pPr algn="ctr"/>
+                      <a:r>
+                        <a:rPr sz="1100" b="0">
+                          <a:solidFill>
+                            <a:srgbClr val="2F2F2F"/>
+                          </a:solidFill>
+                          <a:latin typeface="Yu Gothic"/>
+                        </a:rPr>
+                        <a:t>入荷予定 S12（仮採番）</a:t>
+                      </a:r>
+                    </a:p>
+                  </a:txBody>
+                  <a:tcPr anchor="ctr"/>
+                </a:tc>
                 <a:tc>
                   <a:txBody>
                     <a:bodyPr/>
@@ -7958,7 +7784,104 @@
                           </a:solidFill>
                           <a:latin typeface="Yu Gothic"/>
                         </a:rPr>
-                        <a:t>18.5</a:t>
+                        <a:t>5.0</a:t>
+                      </a:r>
+                    </a:p>
+                  </a:txBody>
+                  <a:tcPr anchor="ctr"/>
+                </a:tc>
+                <a:tc>
+                  <a:txBody>
+                    <a:bodyPr/>
+                    <a:lstStyle/>
+                    <a:p>
+                      <a:pPr algn="l"/>
+                      <a:r>
+                        <a:rPr sz="1100" b="0">
+                          <a:solidFill>
+                            <a:srgbClr val="2F2F2F"/>
+                          </a:solidFill>
+                          <a:latin typeface="Yu Gothic"/>
+                        </a:rPr>
+                        <a:t>15.0</a:t>
+                      </a:r>
+                    </a:p>
+                  </a:txBody>
+                  <a:tcPr anchor="ctr"/>
+                </a:tc>
+                <a:tc>
+                  <a:txBody>
+                    <a:bodyPr/>
+                    <a:lstStyle/>
+                    <a:p>
+                      <a:pPr algn="l"/>
+                      <a:r>
+                        <a:rPr sz="1100" b="0">
+                          <a:solidFill>
+                            <a:srgbClr val="2F2F2F"/>
+                          </a:solidFill>
+                          <a:latin typeface="Yu Gothic"/>
+                        </a:rPr>
+                        <a:t>2.5</a:t>
+                      </a:r>
+                    </a:p>
+                  </a:txBody>
+                  <a:tcPr anchor="ctr"/>
+                </a:tc>
+                <a:tc>
+                  <a:txBody>
+                    <a:bodyPr/>
+                    <a:lstStyle/>
+                    <a:p>
+                      <a:pPr algn="l"/>
+                      <a:r>
+                        <a:rPr sz="1100" b="0">
+                          <a:solidFill>
+                            <a:srgbClr val="2F2F2F"/>
+                          </a:solidFill>
+                          <a:latin typeface="Yu Gothic"/>
+                        </a:rPr>
+                        <a:t>22.5</a:t>
+                      </a:r>
+                    </a:p>
+                  </a:txBody>
+                  <a:tcPr anchor="ctr"/>
+                </a:tc>
+                <a:tc>
+                  <a:txBody>
+                    <a:bodyPr/>
+                    <a:lstStyle/>
+                    <a:p>
+                      <a:pPr algn="l"/>
+                      <a:r>
+                        <a:rPr sz="1100" b="0">
+                          <a:solidFill>
+                            <a:srgbClr val="2F2F2F"/>
+                          </a:solidFill>
+                          <a:latin typeface="Yu Gothic"/>
+                        </a:rPr>
+                        <a:t>PC/CKは別SQL。DBGET＋待ち合わせ</a:t>
+                      </a:r>
+                    </a:p>
+                  </a:txBody>
+                  <a:tcPr anchor="ctr"/>
+                </a:tc>
+              </a:tr>
+              <a:tr h="292608">
+                <a:tc>
+                  <a:txBody>
+                    <a:bodyPr/>
+                    <a:lstStyle/>
+                    <a:p>
+                      <a:pPr algn="ctr"/>
+                      <a:r>
+                        <a:rPr sz="1100" b="0">
+                          <a:solidFill>
+                            <a:srgbClr val="2F2F2F"/>
+                          </a:solidFill>
+                          <a:latin typeface="Yu Gothic"/>
+                        </a:rPr>
+                        <a:t>発注スケジュール S13（仮採番）</a:t>
                       </a:r>
                     </a:p>
                   </a:txBody>
@@ -7981,7 +7904,7 @@
                           </a:solidFill>
                           <a:latin typeface="Yu Gothic"/>
                         </a:rPr>
-                        <a:t>ベンダー流用。伝票区分差分＋PC/CK振替</a:t>
+                        <a:t>5.0</a:t>
                       </a:r>
                     </a:p>
                   </a:txBody>
@@ -7991,14 +7914,12 @@
                     </a:solidFill>
                   </a:tcPr>
                 </a:tc>
-              </a:tr>
-              <a:tr h="292608">
-                <a:tc>
-                  <a:txBody>
-                    <a:bodyPr/>
-                    <a:lstStyle/>
-                    <a:p>
-                      <a:pPr algn="ctr"/>
+                <a:tc>
+                  <a:txBody>
+                    <a:bodyPr/>
+                    <a:lstStyle/>
+                    <a:p>
+                      <a:pPr algn="l"/>
                       <a:r>
                         <a:rPr sz="1100" b="0">
                           <a:solidFill>
@@ -8006,142 +7927,7 @@
                           </a:solidFill>
                           <a:latin typeface="Yu Gothic"/>
                         </a:rPr>
-                        <a:t>入荷予定</a:t>
-                      </a:r>
-                    </a:p>
-                  </a:txBody>
-                  <a:tcPr anchor="ctr"/>
-                </a:tc>
-                <a:tc>
-                  <a:txBody>
-                    <a:bodyPr/>
-                    <a:lstStyle/>
-                    <a:p>
-                      <a:pPr algn="l"/>
-                      <a:r>
-                        <a:rPr sz="1100" b="0">
-                          <a:solidFill>
-                            <a:srgbClr val="2F2F2F"/>
-                          </a:solidFill>
-                          <a:latin typeface="Yu Gothic"/>
-                        </a:rPr>
-                        <a:t>S12</a:t>
-                      </a:r>
-                    </a:p>
-                  </a:txBody>
-                  <a:tcPr anchor="ctr"/>
-                </a:tc>
-                <a:tc>
-                  <a:txBody>
-                    <a:bodyPr/>
-                    <a:lstStyle/>
-                    <a:p>
-                      <a:pPr algn="l"/>
-                      <a:r>
-                        <a:rPr sz="1100" b="0">
-                          <a:solidFill>
-                            <a:srgbClr val="2F2F2F"/>
-                          </a:solidFill>
-                          <a:latin typeface="Yu Gothic"/>
-                        </a:rPr>
-                        <a:t>5.0</a:t>
-                      </a:r>
-                    </a:p>
-                  </a:txBody>
-                  <a:tcPr anchor="ctr"/>
-                </a:tc>
-                <a:tc>
-                  <a:txBody>
-                    <a:bodyPr/>
-                    <a:lstStyle/>
-                    <a:p>
-                      <a:pPr algn="l"/>
-                      <a:r>
-                        <a:rPr sz="1100" b="0">
-                          <a:solidFill>
-                            <a:srgbClr val="2F2F2F"/>
-                          </a:solidFill>
-                          <a:latin typeface="Yu Gothic"/>
-                        </a:rPr>
                         <a:t>15.0</a:t>
-                      </a:r>
-                    </a:p>
-                  </a:txBody>
-                  <a:tcPr anchor="ctr"/>
-                </a:tc>
-                <a:tc>
-                  <a:txBody>
-                    <a:bodyPr/>
-                    <a:lstStyle/>
-                    <a:p>
-                      <a:pPr algn="l"/>
-                      <a:r>
-                        <a:rPr sz="1100" b="0">
-                          <a:solidFill>
-                            <a:srgbClr val="2F2F2F"/>
-                          </a:solidFill>
-                          <a:latin typeface="Yu Gothic"/>
-                        </a:rPr>
-                        <a:t>2.5</a:t>
-                      </a:r>
-                    </a:p>
-                  </a:txBody>
-                  <a:tcPr anchor="ctr"/>
-                </a:tc>
-                <a:tc>
-                  <a:txBody>
-                    <a:bodyPr/>
-                    <a:lstStyle/>
-                    <a:p>
-                      <a:pPr algn="l"/>
-                      <a:r>
-                        <a:rPr sz="1100" b="0">
-                          <a:solidFill>
-                            <a:srgbClr val="2F2F2F"/>
-                          </a:solidFill>
-                          <a:latin typeface="Yu Gothic"/>
-                        </a:rPr>
-                        <a:t>22.5</a:t>
-                      </a:r>
-                    </a:p>
-                  </a:txBody>
-                  <a:tcPr anchor="ctr"/>
-                </a:tc>
-                <a:tc>
-                  <a:txBody>
-                    <a:bodyPr/>
-                    <a:lstStyle/>
-                    <a:p>
-                      <a:pPr algn="l"/>
-                      <a:r>
-                        <a:rPr sz="1100" b="0">
-                          <a:solidFill>
-                            <a:srgbClr val="2F2F2F"/>
-                          </a:solidFill>
-                          <a:latin typeface="Yu Gothic"/>
-                        </a:rPr>
-                        <a:t>ベンダー流用。PC/CKは別SQL。DBGET2系統＋待ち合わせ</a:t>
-                      </a:r>
-                    </a:p>
-                  </a:txBody>
-                  <a:tcPr anchor="ctr"/>
-                </a:tc>
-              </a:tr>
-              <a:tr h="292608">
-                <a:tc>
-                  <a:txBody>
-                    <a:bodyPr/>
-                    <a:lstStyle/>
-                    <a:p>
-                      <a:pPr algn="ctr"/>
-                      <a:r>
-                        <a:rPr sz="1100" b="0">
-                          <a:solidFill>
-                            <a:srgbClr val="2F2F2F"/>
-                          </a:solidFill>
-                          <a:latin typeface="Yu Gothic"/>
-                        </a:rPr>
-                        <a:t>発注スケジュール</a:t>
                       </a:r>
                     </a:p>
                   </a:txBody>
@@ -8164,7 +7950,7 @@
                           </a:solidFill>
                           <a:latin typeface="Yu Gothic"/>
                         </a:rPr>
-                        <a:t>S13</a:t>
+                        <a:t>2.5</a:t>
                       </a:r>
                     </a:p>
                   </a:txBody>
@@ -8187,7 +7973,7 @@
                           </a:solidFill>
                           <a:latin typeface="Yu Gothic"/>
                         </a:rPr>
-                        <a:t>5.0</a:t>
+                        <a:t>22.5</a:t>
                       </a:r>
                     </a:p>
                   </a:txBody>
@@ -8210,7 +7996,7 @@
                           </a:solidFill>
                           <a:latin typeface="Yu Gothic"/>
                         </a:rPr>
-                        <a:t>15.0</a:t>
+                        <a:t>PC/CKは別SQL。DBGET＋待ち合わせ</a:t>
                       </a:r>
                     </a:p>
                   </a:txBody>
@@ -8220,75 +8006,6 @@
                     </a:solidFill>
                   </a:tcPr>
                 </a:tc>
-                <a:tc>
-                  <a:txBody>
-                    <a:bodyPr/>
-                    <a:lstStyle/>
-                    <a:p>
-                      <a:pPr algn="l"/>
-                      <a:r>
-                        <a:rPr sz="1100" b="0">
-                          <a:solidFill>
-                            <a:srgbClr val="2F2F2F"/>
-                          </a:solidFill>
-                          <a:latin typeface="Yu Gothic"/>
-                        </a:rPr>
-                        <a:t>2.5</a:t>
-                      </a:r>
-                    </a:p>
-                  </a:txBody>
-                  <a:tcPr anchor="ctr">
-                    <a:solidFill>
-                      <a:srgbClr val="F5F8FB"/>
-                    </a:solidFill>
-                  </a:tcPr>
-                </a:tc>
-                <a:tc>
-                  <a:txBody>
-                    <a:bodyPr/>
-                    <a:lstStyle/>
-                    <a:p>
-                      <a:pPr algn="l"/>
-                      <a:r>
-                        <a:rPr sz="1100" b="0">
-                          <a:solidFill>
-                            <a:srgbClr val="2F2F2F"/>
-                          </a:solidFill>
-                          <a:latin typeface="Yu Gothic"/>
-                        </a:rPr>
-                        <a:t>22.5</a:t>
-                      </a:r>
-                    </a:p>
-                  </a:txBody>
-                  <a:tcPr anchor="ctr">
-                    <a:solidFill>
-                      <a:srgbClr val="F5F8FB"/>
-                    </a:solidFill>
-                  </a:tcPr>
-                </a:tc>
-                <a:tc>
-                  <a:txBody>
-                    <a:bodyPr/>
-                    <a:lstStyle/>
-                    <a:p>
-                      <a:pPr algn="l"/>
-                      <a:r>
-                        <a:rPr sz="1100" b="0">
-                          <a:solidFill>
-                            <a:srgbClr val="2F2F2F"/>
-                          </a:solidFill>
-                          <a:latin typeface="Yu Gothic"/>
-                        </a:rPr>
-                        <a:t>ベンダー流用。PC/CKは別SQL。DBGET2系統＋待ち合わせ</a:t>
-                      </a:r>
-                    </a:p>
-                  </a:txBody>
-                  <a:tcPr anchor="ctr">
-                    <a:solidFill>
-                      <a:srgbClr val="F5F8FB"/>
-                    </a:solidFill>
-                  </a:tcPr>
-                </a:tc>
               </a:tr>
               <a:tr h="292608">
                 <a:tc>
@@ -8306,20 +8023,6 @@
                         </a:rPr>
                         <a:t>A小計</a:t>
                       </a:r>
-                    </a:p>
-                  </a:txBody>
-                  <a:tcPr anchor="ctr">
-                    <a:solidFill>
-                      <a:srgbClr val="E2F0D9"/>
-                    </a:solidFill>
-                  </a:tcPr>
-                </a:tc>
-                <a:tc>
-                  <a:txBody>
-                    <a:bodyPr/>
-                    <a:lstStyle/>
-                    <a:p>
-                      <a:pPr algn="l"/>
                     </a:p>
                   </a:txBody>
                   <a:tcPr anchor="ctr">
@@ -8499,7 +8202,7 @@
                 </a:solidFill>
                 <a:latin typeface="Yu Gothic"/>
               </a:rPr>
-              <a:t>A の見積リスク（本案で上振れを大きく載せない理由）</a:t>
+              <a:t>Aの上振れを大きく載せていない理由</a:t>
             </a:r>
           </a:p>
           <a:p>
@@ -8518,7 +8221,7 @@
                 </a:solidFill>
                 <a:latin typeface="Yu Gothic"/>
               </a:rPr>
-              <a:t>要件の骨格は 9/18 会議。本数判定は 9/29。残リスクは項目精査・伝票区分・GCS、発注統合レイアウト差、S12/S13のSQLと作成時刻。覆りは再見積。</a:t>
+              <a:t>要件の骨格は 9/18 会議。本数は 9/29。残件は項目精査・伝票区分・GCS、発注統合レイアウト差、入荷予定・発注スケジュールのSQLと作成時刻。覆りは再見積。</a:t>
             </a:r>
           </a:p>
         </p:txBody>
@@ -8553,7 +8256,7 @@
                 </a:solidFill>
                 <a:latin typeface="Yu Gothic"/>
               </a:rPr>
-              <a:t>西友MD基幹統合｜生鮮IF増分見積（標準案）説明｜2026-09-21 Rev.e</a:t>
+              <a:t>西友MD基幹統合｜生鮮IF増分見積｜2026-09-30</a:t>
             </a:r>
           </a:p>
         </p:txBody>
@@ -8658,7 +8361,7 @@
                 </a:solidFill>
                 <a:latin typeface="Yu Gothic"/>
               </a:rPr>
-              <a:t>5. 最重要リスク｜判定後に残るもの</a:t>
+              <a:t>5. 流用は未確認</a:t>
             </a:r>
           </a:p>
         </p:txBody>
@@ -8693,7 +8396,7 @@
                 </a:solidFill>
                 <a:latin typeface="Yu Gothic"/>
               </a:rPr>
-              <a:t>12本流用は確定。残件はGCS・伝票区分・水煮・SQL作成時刻</a:t>
+              <a:t>先方協議では12本流用可。当社未同席。残件はGCS・伝票区分・水煮・SQL作成時刻</a:t>
             </a:r>
           </a:p>
         </p:txBody>
@@ -8768,7 +8471,7 @@
                 </a:solidFill>
                 <a:latin typeface="Yu Gothic"/>
               </a:rPr>
-              <a:t>・店舗系12本は非生鮮と同じ（流用）</a:t>
+              <a:t>・店舗系12本は先方協議では非生鮮と同じ（流用）。当社は未同席</a:t>
             </a:r>
           </a:p>
           <a:p>
@@ -8957,7 +8660,7 @@
                 </a:solidFill>
                 <a:latin typeface="Yu Gothic"/>
               </a:rPr>
-              <a:t>B1 15人日＝突合と残件</a:t>
+              <a:t>B1（流用確認・残件） 15人日＝突合と残件</a:t>
             </a:r>
           </a:p>
           <a:p>
@@ -9033,7 +8736,7 @@
                 </a:solidFill>
                 <a:latin typeface="Yu Gothic"/>
               </a:rPr>
-              <a:t>B2 0人日＝マスタ本体IFなし</a:t>
+              <a:t>B2（マスタ本体IF） 0人日</a:t>
             </a:r>
           </a:p>
           <a:p>
@@ -9071,7 +8774,7 @@
                 </a:solidFill>
                 <a:latin typeface="Yu Gothic"/>
               </a:rPr>
-              <a:t>B3 5人日＝伝票区分・振替の軽微注記</a:t>
+              <a:t>B3（非生鮮Phase2波及） 5人日＝伝票区分・振替の軽微注記</a:t>
             </a:r>
           </a:p>
           <a:p>
@@ -9144,7 +8847,7 @@
                 </a:solidFill>
                 <a:latin typeface="Yu Gothic"/>
               </a:rPr>
-              <a:t>西友MD基幹統合｜生鮮IF増分見積（標準案）説明｜2026-09-21 Rev.e</a:t>
+              <a:t>西友MD基幹統合｜生鮮IF増分見積｜2026-09-30</a:t>
             </a:r>
           </a:p>
         </p:txBody>
@@ -9249,7 +8952,7 @@
                 </a:solidFill>
                 <a:latin typeface="Yu Gothic"/>
               </a:rPr>
-              <a:t>6. 非生鮮Phase2への波及リスク（B3）</a:t>
+              <a:t>6. B3（非生鮮Phase2波及）</a:t>
             </a:r>
           </a:p>
         </p:txBody>
@@ -9284,7 +8987,7 @@
                 </a:solidFill>
                 <a:latin typeface="Yu Gothic"/>
               </a:rPr>
-              <a:t>PMI課題 Sinops非生鮮のPhase2。契約額は据え置き。手戻り工数は増分側に計上</a:t>
+              <a:t>非生鮮Phase2の契約額は据え置き。手戻りは増分側に計上</a:t>
             </a:r>
           </a:p>
         </p:txBody>
@@ -9326,7 +9029,7 @@
                           </a:solidFill>
                           <a:latin typeface="Yu Gothic"/>
                         </a:rPr>
-                        <a:t>既存IF</a:t>
+                        <a:t>対象</a:t>
                       </a:r>
                     </a:p>
                   </a:txBody>
@@ -9372,7 +9075,7 @@
                           </a:solidFill>
                           <a:latin typeface="Yu Gothic"/>
                         </a:rPr>
-                        <a:t>顕在化したときの姿</a:t>
+                        <a:t>見積上の扱い</a:t>
                       </a:r>
                     </a:p>
                   </a:txBody>
@@ -9397,7 +9100,7 @@
                           </a:solidFill>
                           <a:latin typeface="Yu Gothic"/>
                         </a:rPr>
-                        <a:t>01–05／06–10／14/15</a:t>
+                        <a:t>店舗系マスタ・実績12本</a:t>
                       </a:r>
                     </a:p>
                   </a:txBody>
@@ -9416,7 +9119,7 @@
                           </a:solidFill>
                           <a:latin typeface="Yu Gothic"/>
                         </a:rPr>
-                        <a:t>9/29判定では非生鮮と同じ</a:t>
+                        <a:t>先方協議では非生鮮と同じ。当社未確認</a:t>
                       </a:r>
                     </a:p>
                   </a:txBody>
@@ -9435,7 +9138,7 @@
                           </a:solidFill>
                           <a:latin typeface="Yu Gothic"/>
                         </a:rPr>
-                        <a:t>流用。本体IFなし。B1で突合</a:t>
+                        <a:t>流用仮置き。本体IFなし。B1で突合</a:t>
                       </a:r>
                     </a:p>
                   </a:txBody>
@@ -9456,7 +9159,7 @@
                           </a:solidFill>
                           <a:latin typeface="Yu Gothic"/>
                         </a:rPr>
-                        <a:t>11 入荷実績</a:t>
+                        <a:t>入荷実績 S11（仮採番）</a:t>
                       </a:r>
                     </a:p>
                   </a:txBody>
@@ -9502,7 +9205,7 @@
                           </a:solidFill>
                           <a:latin typeface="Yu Gothic"/>
                         </a:rPr>
-                        <a:t>差分IF（A）</a:t>
+                        <a:t>A 差分</a:t>
                       </a:r>
                     </a:p>
                   </a:txBody>
@@ -9527,7 +9230,7 @@
                           </a:solidFill>
                           <a:latin typeface="Yu Gothic"/>
                         </a:rPr>
-                        <a:t>12 入荷予定</a:t>
+                        <a:t>入荷予定 S12（仮採番）</a:t>
                       </a:r>
                     </a:p>
                   </a:txBody>
@@ -9565,7 +9268,7 @@
                           </a:solidFill>
                           <a:latin typeface="Yu Gothic"/>
                         </a:rPr>
-                        <a:t>差分IF（A）Layer①に加算</a:t>
+                        <a:t>A 差分。Layer①に加算</a:t>
                       </a:r>
                     </a:p>
                   </a:txBody>
@@ -9586,7 +9289,7 @@
                           </a:solidFill>
                           <a:latin typeface="Yu Gothic"/>
                         </a:rPr>
-                        <a:t>13 発注スケジュール</a:t>
+                        <a:t>発注スケジュール S13（仮採番）</a:t>
                       </a:r>
                     </a:p>
                   </a:txBody>
@@ -9632,7 +9335,7 @@
                           </a:solidFill>
                           <a:latin typeface="Yu Gothic"/>
                         </a:rPr>
-                        <a:t>差分IF（A）Layer①に加算</a:t>
+                        <a:t>A 差分。Layer①に加算</a:t>
                       </a:r>
                     </a:p>
                   </a:txBody>
@@ -9657,7 +9360,7 @@
                           </a:solidFill>
                           <a:latin typeface="Yu Gothic"/>
                         </a:rPr>
-                        <a:t>24/25 勧告ファイル</a:t>
+                        <a:t>発注勧告 当日・翌日 S24／S25（仮採番）</a:t>
                       </a:r>
                     </a:p>
                   </a:txBody>
@@ -9676,7 +9379,7 @@
                           </a:solidFill>
                           <a:latin typeface="Yu Gothic"/>
                         </a:rPr>
-                        <a:t>2ファイル／1.5本換算</a:t>
+                        <a:t>2ファイル／1.5本</a:t>
                       </a:r>
                     </a:p>
                   </a:txBody>
@@ -9695,7 +9398,7 @@
                           </a:solidFill>
                           <a:latin typeface="Yu Gothic"/>
                         </a:rPr>
-                        <a:t>S24=1本、S25=0.5本</a:t>
+                        <a:t>当日1本、翌日0.5本</a:t>
                       </a:r>
                     </a:p>
                   </a:txBody>
@@ -9716,7 +9419,7 @@
                           </a:solidFill>
                           <a:latin typeface="Yu Gothic"/>
                         </a:rPr>
-                        <a:t>勧告→発注統合</a:t>
+                        <a:t>勧告→発注統合 S26（仮採番）</a:t>
                       </a:r>
                     </a:p>
                   </a:txBody>
@@ -9762,7 +9465,7 @@
                           </a:solidFill>
                           <a:latin typeface="Yu Gothic"/>
                         </a:rPr>
-                        <a:t>新規IF（A）S26。参照は非生鮮24/25</a:t>
+                        <a:t>A 新規。参照は非生鮮発注勧告</a:t>
                       </a:r>
                     </a:p>
                   </a:txBody>
@@ -9866,7 +9569,7 @@
                 </a:solidFill>
                 <a:latin typeface="Yu Gothic"/>
               </a:rPr>
-              <a:t>西友MD基幹統合｜生鮮IF増分見積（標準案）説明｜2026-09-21 Rev.e</a:t>
+              <a:t>西友MD基幹統合｜生鮮IF増分見積｜2026-09-30</a:t>
             </a:r>
           </a:p>
         </p:txBody>
@@ -9971,7 +9674,7 @@
                 </a:solidFill>
                 <a:latin typeface="Yu Gothic"/>
               </a:rPr>
-              <a:t>7. 判定ゲートと再見積トリガー（リスク管理の運用）</a:t>
+              <a:t>7. 進め方と再見積</a:t>
             </a:r>
           </a:p>
         </p:txBody>
@@ -10006,7 +9709,7 @@
                 </a:solidFill>
                 <a:latin typeface="Yu Gothic"/>
               </a:rPr>
-              <a:t>数字を固定契約にしすぎないための説明スライド</a:t>
+              <a:t>提示値は確定請負ではない</a:t>
             </a:r>
           </a:p>
         </p:txBody>
@@ -10062,7 +9765,7 @@
                 </a:solidFill>
                 <a:latin typeface="Yu Gothic"/>
               </a:rPr>
-              <a:t>① B1 突合</a:t>
+              <a:t>① B1（流用確認・残件）</a:t>
             </a:r>
           </a:p>
           <a:p>
@@ -10138,7 +9841,7 @@
                 </a:solidFill>
                 <a:latin typeface="Yu Gothic"/>
               </a:rPr>
-              <a:t>② A 着手</a:t>
+              <a:t>② A（新規／差分IF）</a:t>
             </a:r>
           </a:p>
           <a:p>
@@ -10158,7 +9861,7 @@
                 <a:latin typeface="Yu Gothic"/>
               </a:rPr>
               <a:t>差分／新規6本は
-マッピングから</a:t>
+Mappingから</a:t>
             </a:r>
           </a:p>
         </p:txBody>
@@ -10214,7 +9917,7 @@
                 </a:solidFill>
                 <a:latin typeface="Yu Gothic"/>
               </a:rPr>
-              <a:t>③ B2 維持</a:t>
+              <a:t>③ B2（マスタ本体IF）</a:t>
             </a:r>
           </a:p>
           <a:p>
@@ -10309,7 +10012,7 @@
                 </a:solidFill>
                 <a:latin typeface="Yu Gothic"/>
               </a:rPr>
-              <a:t>軽微は B3＝5
+              <a:t>軽微は B3＝5人日
 超過なら再見積</a:t>
             </a:r>
           </a:p>
@@ -10366,7 +10069,7 @@
                 </a:solidFill>
                 <a:latin typeface="Yu Gothic"/>
               </a:rPr>
-              <a:t>再見積を上げるトリガー（説明用）</a:t>
+              <a:t>再見積になるとき</a:t>
             </a:r>
           </a:p>
           <a:p>
@@ -10442,7 +10145,7 @@
                 </a:solidFill>
                 <a:latin typeface="Yu Gothic"/>
               </a:rPr>
-              <a:t>・S12/S13のSQL接続が重い、生鮮データの作成時刻が待ち合わせでは収まらない</a:t>
+              <a:t>・入荷予定・発注スケジュールのSQL接続が重い、生鮮データの作成時刻が待ち合わせでは収まらない</a:t>
             </a:r>
           </a:p>
           <a:p>
@@ -10461,7 +10164,7 @@
                 </a:solidFill>
                 <a:latin typeface="Yu Gothic"/>
               </a:rPr>
-              <a:t>・目安：直接工数が本案想定を大きく超える場合は増分再見積</a:t>
+              <a:t>・直接工数が本案想定を大きく超える場合は増分再見積</a:t>
             </a:r>
           </a:p>
         </p:txBody>
@@ -10496,7 +10199,7 @@
                 </a:solidFill>
                 <a:latin typeface="Yu Gothic"/>
               </a:rPr>
-              <a:t>西友MD基幹統合｜生鮮IF増分見積（標準案）説明｜2026-09-21 Rev.e</a:t>
+              <a:t>西友MD基幹統合｜生鮮IF増分見積｜2026-09-30</a:t>
             </a:r>
           </a:p>
         </p:txBody>
@@ -10636,7 +10339,7 @@
                 </a:solidFill>
                 <a:latin typeface="Yu Gothic"/>
               </a:rPr>
-              <a:t>スコープ外を明示しないと、後から「全部入り」に読まれる</a:t>
+              <a:t>Phase2は詳細設計・開発・単体まで</a:t>
             </a:r>
           </a:p>
         </p:txBody>
@@ -10692,7 +10395,7 @@
                 </a:solidFill>
                 <a:latin typeface="Yu Gothic"/>
               </a:rPr>
-              <a:t>含む（本案の範囲）</a:t>
+              <a:t>含む</a:t>
             </a:r>
           </a:p>
           <a:p>
@@ -10711,7 +10414,7 @@
                 </a:solidFill>
                 <a:latin typeface="Yu Gothic"/>
               </a:rPr>
-              <a:t>・調査用表・Mapping（Phase1）</a:t>
+              <a:t>・調査用表・①②③ Mapping（Phase1）</a:t>
             </a:r>
           </a:p>
           <a:p>
@@ -10749,7 +10452,7 @@
                 </a:solidFill>
                 <a:latin typeface="Yu Gothic"/>
               </a:rPr>
-              <a:t>・先行トラン確定IF 6本</a:t>
+              <a:t>・Aの6本（勧告・変換・入荷・日程）</a:t>
             </a:r>
           </a:p>
           <a:p>
@@ -10787,7 +10490,7 @@
                 </a:solidFill>
                 <a:latin typeface="Yu Gothic"/>
               </a:rPr>
-              <a:t>・マスタ本体IFは0（B2）。軽微波及（B3）</a:t>
+              <a:t>・B2＝0。軽微波及（B3）</a:t>
             </a:r>
           </a:p>
           <a:p>
@@ -10806,7 +10509,7 @@
                 </a:solidFill>
                 <a:latin typeface="Yu Gothic"/>
               </a:rPr>
-              <a:t>・増分PJ管理按分（C）</a:t>
+              <a:t>・PJ管理按分（C）</a:t>
             </a:r>
           </a:p>
           <a:p>
@@ -10825,7 +10528,7 @@
                 </a:solidFill>
                 <a:latin typeface="Yu Gothic"/>
               </a:rPr>
-              <a:t>・生鮮マスタのGCSアップロード確認・作業前提</a:t>
+              <a:t>・生鮮マスタのGCS確認・作業前提</a:t>
             </a:r>
           </a:p>
         </p:txBody>
@@ -10881,7 +10584,7 @@
                 </a:solidFill>
                 <a:latin typeface="Yu Gothic"/>
               </a:rPr>
-              <a:t>含まない（明示除外）</a:t>
+              <a:t>含まない</a:t>
             </a:r>
           </a:p>
           <a:p>
@@ -10995,7 +10698,7 @@
                 </a:solidFill>
                 <a:latin typeface="Yu Gothic"/>
               </a:rPr>
-              <a:t>・PMI課題 Sinops非生鮮のPhase2・共通基盤43・既存PJ50の契約変更</a:t>
+              <a:t>・非生鮮Phase2・共通基盤43・既存PJ50の契約変更</a:t>
             </a:r>
           </a:p>
         </p:txBody>
@@ -11030,7 +10733,7 @@
                 </a:solidFill>
                 <a:latin typeface="Yu Gothic"/>
               </a:rPr>
-              <a:t>西友MD基幹統合｜生鮮IF増分見積（標準案）説明｜2026-09-21 Rev.e</a:t>
+              <a:t>西友MD基幹統合｜生鮮IF増分見積｜2026-09-30</a:t>
             </a:r>
           </a:p>
         </p:txBody>

</xml_diff>